<commit_message>
Added to here page ...
</commit_message>
<xml_diff>
--- a/lectures/Week02_ObjectOriented/1_ObjectOriented_V4.pptx
+++ b/lectures/Week02_ObjectOriented/1_ObjectOriented_V4.pptx
@@ -6,10 +6,10 @@
     <p:sldMasterId id="2147483674" r:id="rId2"/>
   </p:sldMasterIdLst>
   <p:notesMasterIdLst>
-    <p:notesMasterId r:id="rId62"/>
+    <p:notesMasterId r:id="rId63"/>
   </p:notesMasterIdLst>
   <p:handoutMasterIdLst>
-    <p:handoutMasterId r:id="rId63"/>
+    <p:handoutMasterId r:id="rId64"/>
   </p:handoutMasterIdLst>
   <p:sldIdLst>
     <p:sldId id="333" r:id="rId3"/>
@@ -71,6 +71,7 @@
     <p:sldId id="416" r:id="rId59"/>
     <p:sldId id="418" r:id="rId60"/>
     <p:sldId id="419" r:id="rId61"/>
+    <p:sldId id="509" r:id="rId62"/>
   </p:sldIdLst>
   <p:sldSz cx="12192000" cy="6858000"/>
   <p:notesSz cx="7010400" cy="9296400"/>
@@ -259,7 +260,7 @@
           <a:p>
             <a:fld id="{8E938536-29D3-49BD-A567-41CAF057586A}" type="datetimeFigureOut">
               <a:rPr lang="en-US" smtClean="0"/>
-              <a:t>8/21/2026</a:t>
+              <a:t>9/22/2026</a:t>
             </a:fld>
             <a:endParaRPr lang="en-US"/>
           </a:p>
@@ -424,7 +425,7 @@
           <a:p>
             <a:fld id="{71559A16-B3AD-4CE2-9A5E-FAAD3C2C27CA}" type="datetimeFigureOut">
               <a:rPr lang="en-US" smtClean="0"/>
-              <a:t>8/21/2026</a:t>
+              <a:t>9/22/2026</a:t>
             </a:fld>
             <a:endParaRPr lang="en-US"/>
           </a:p>
@@ -3283,7 +3284,7 @@
           <a:p>
             <a:fld id="{14C656F1-AD33-45CA-85C7-DC330226D9FE}" type="datetime1">
               <a:rPr lang="en-US" smtClean="0"/>
-              <a:t>8/21/2026</a:t>
+              <a:t>9/22/2026</a:t>
             </a:fld>
             <a:endParaRPr lang="en-US"/>
           </a:p>
@@ -3537,7 +3538,7 @@
             </a:pPr>
             <a:fld id="{EEF94DD4-5043-4A3A-99E2-3B90AB8E4ADF}" type="datetime1">
               <a:rPr lang="en-US" smtClean="0"/>
-              <a:t>8/21/2026</a:t>
+              <a:t>9/22/2026</a:t>
             </a:fld>
             <a:endParaRPr lang="en-US"/>
           </a:p>
@@ -37035,6 +37036,70 @@
     <a:masterClrMapping/>
   </p:clrMapOvr>
   <p:transition/>
+</p:sld>
+</file>
+
+<file path=ppt/slides/slide60.xml><?xml version="1.0" encoding="utf-8"?>
+<p:sld xmlns:a="http://schemas.openxmlformats.org/drawingml/2006/main" xmlns:r="http://schemas.openxmlformats.org/officeDocument/2006/relationships" xmlns:p="http://schemas.openxmlformats.org/presentationml/2006/main">
+  <p:cSld>
+    <p:spTree>
+      <p:nvGrpSpPr>
+        <p:cNvPr id="1" name="">
+          <a:extLst>
+            <a:ext uri="{FF2B5EF4-FFF2-40B4-BE49-F238E27FC236}">
+              <a16:creationId xmlns:a16="http://schemas.microsoft.com/office/drawing/2014/main" id="{84DA25F2-3AE0-BDCF-0880-EDD5EEF55E54}"/>
+            </a:ext>
+          </a:extLst>
+        </p:cNvPr>
+        <p:cNvGrpSpPr/>
+        <p:nvPr/>
+      </p:nvGrpSpPr>
+      <p:grpSpPr>
+        <a:xfrm>
+          <a:off x="0" y="0"/>
+          <a:ext cx="0" cy="0"/>
+          <a:chOff x="0" y="0"/>
+          <a:chExt cx="0" cy="0"/>
+        </a:xfrm>
+      </p:grpSpPr>
+      <p:sp>
+        <p:nvSpPr>
+          <p:cNvPr id="2" name="Title 1">
+            <a:extLst>
+              <a:ext uri="{FF2B5EF4-FFF2-40B4-BE49-F238E27FC236}">
+                <a16:creationId xmlns:a16="http://schemas.microsoft.com/office/drawing/2014/main" id="{6EAE57A2-3A61-C5F8-EEFD-EA2961784338}"/>
+              </a:ext>
+            </a:extLst>
+          </p:cNvPr>
+          <p:cNvSpPr>
+            <a:spLocks noGrp="1"/>
+          </p:cNvSpPr>
+          <p:nvPr>
+            <p:ph type="ctrTitle"/>
+          </p:nvPr>
+        </p:nvSpPr>
+        <p:spPr/>
+        <p:txBody>
+          <a:bodyPr/>
+          <a:lstStyle/>
+          <a:p>
+            <a:r>
+              <a:rPr lang="en-US" dirty="0"/>
+              <a:t>… to here …</a:t>
+            </a:r>
+          </a:p>
+        </p:txBody>
+      </p:sp>
+    </p:spTree>
+    <p:extLst>
+      <p:ext uri="{BB962C8B-B14F-4D97-AF65-F5344CB8AC3E}">
+        <p14:creationId xmlns:p14="http://schemas.microsoft.com/office/powerpoint/2010/main" val="2815624037"/>
+      </p:ext>
+    </p:extLst>
+  </p:cSld>
+  <p:clrMapOvr>
+    <a:masterClrMapping/>
+  </p:clrMapOvr>
 </p:sld>
 </file>
 

</xml_diff>

<commit_message>
COEN to CSEN change
</commit_message>
<xml_diff>
--- a/lectures/Week02_ObjectOriented/1_ObjectOriented_V4.pptx
+++ b/lectures/Week02_ObjectOriented/1_ObjectOriented_V4.pptx
@@ -260,7 +260,7 @@
           <a:p>
             <a:fld id="{8E938536-29D3-49BD-A567-41CAF057586A}" type="datetimeFigureOut">
               <a:rPr lang="en-US" smtClean="0"/>
-              <a:t>9/22/2026</a:t>
+              <a:t>9/23/2026</a:t>
             </a:fld>
             <a:endParaRPr lang="en-US"/>
           </a:p>
@@ -425,7 +425,7 @@
           <a:p>
             <a:fld id="{71559A16-B3AD-4CE2-9A5E-FAAD3C2C27CA}" type="datetimeFigureOut">
               <a:rPr lang="en-US" smtClean="0"/>
-              <a:t>9/22/2026</a:t>
+              <a:t>9/23/2026</a:t>
             </a:fld>
             <a:endParaRPr lang="en-US"/>
           </a:p>
@@ -3284,7 +3284,7 @@
           <a:p>
             <a:fld id="{14C656F1-AD33-45CA-85C7-DC330226D9FE}" type="datetime1">
               <a:rPr lang="en-US" smtClean="0"/>
-              <a:t>9/22/2026</a:t>
+              <a:t>9/23/2026</a:t>
             </a:fld>
             <a:endParaRPr lang="en-US"/>
           </a:p>
@@ -3538,7 +3538,7 @@
             </a:pPr>
             <a:fld id="{EEF94DD4-5043-4A3A-99E2-3B90AB8E4ADF}" type="datetime1">
               <a:rPr lang="en-US" smtClean="0"/>
-              <a:t>9/22/2026</a:t>
+              <a:t>9/23/2026</a:t>
             </a:fld>
             <a:endParaRPr lang="en-US"/>
           </a:p>
@@ -7631,9 +7631,10 @@
           <a:lstStyle/>
           <a:p>
             <a:r>
-              <a:rPr lang="en-US" dirty="0"/>
-              <a:t>COEN160</a:t>
-            </a:r>
+              <a:rPr lang="en-US"/>
+              <a:t>CSEN160</a:t>
+            </a:r>
+            <a:endParaRPr lang="en-US" dirty="0"/>
           </a:p>
         </p:txBody>
       </p:sp>

</xml_diff>

<commit_message>
to here and some minor changes
</commit_message>
<xml_diff>
--- a/lectures/Week02_ObjectOriented/1_ObjectOriented_V4.pptx
+++ b/lectures/Week02_ObjectOriented/1_ObjectOriented_V4.pptx
@@ -19,42 +19,42 @@
     <p:sldId id="421" r:id="rId7"/>
     <p:sldId id="422" r:id="rId8"/>
     <p:sldId id="423" r:id="rId9"/>
-    <p:sldId id="509" r:id="rId10"/>
-    <p:sldId id="424" r:id="rId11"/>
-    <p:sldId id="425" r:id="rId12"/>
-    <p:sldId id="430" r:id="rId13"/>
-    <p:sldId id="360" r:id="rId14"/>
-    <p:sldId id="375" r:id="rId15"/>
-    <p:sldId id="286" r:id="rId16"/>
-    <p:sldId id="374" r:id="rId17"/>
-    <p:sldId id="377" r:id="rId18"/>
-    <p:sldId id="378" r:id="rId19"/>
-    <p:sldId id="298" r:id="rId20"/>
-    <p:sldId id="433" r:id="rId21"/>
-    <p:sldId id="388" r:id="rId22"/>
-    <p:sldId id="362" r:id="rId23"/>
-    <p:sldId id="363" r:id="rId24"/>
-    <p:sldId id="361" r:id="rId25"/>
-    <p:sldId id="290" r:id="rId26"/>
-    <p:sldId id="364" r:id="rId27"/>
-    <p:sldId id="365" r:id="rId28"/>
-    <p:sldId id="366" r:id="rId29"/>
-    <p:sldId id="367" r:id="rId30"/>
-    <p:sldId id="368" r:id="rId31"/>
-    <p:sldId id="380" r:id="rId32"/>
-    <p:sldId id="369" r:id="rId33"/>
-    <p:sldId id="371" r:id="rId34"/>
-    <p:sldId id="381" r:id="rId35"/>
-    <p:sldId id="370" r:id="rId36"/>
-    <p:sldId id="287" r:id="rId37"/>
-    <p:sldId id="393" r:id="rId38"/>
-    <p:sldId id="394" r:id="rId39"/>
-    <p:sldId id="395" r:id="rId40"/>
-    <p:sldId id="396" r:id="rId41"/>
-    <p:sldId id="397" r:id="rId42"/>
-    <p:sldId id="435" r:id="rId43"/>
-    <p:sldId id="436" r:id="rId44"/>
-    <p:sldId id="398" r:id="rId45"/>
+    <p:sldId id="424" r:id="rId10"/>
+    <p:sldId id="425" r:id="rId11"/>
+    <p:sldId id="430" r:id="rId12"/>
+    <p:sldId id="360" r:id="rId13"/>
+    <p:sldId id="375" r:id="rId14"/>
+    <p:sldId id="286" r:id="rId15"/>
+    <p:sldId id="374" r:id="rId16"/>
+    <p:sldId id="377" r:id="rId17"/>
+    <p:sldId id="378" r:id="rId18"/>
+    <p:sldId id="298" r:id="rId19"/>
+    <p:sldId id="433" r:id="rId20"/>
+    <p:sldId id="388" r:id="rId21"/>
+    <p:sldId id="362" r:id="rId22"/>
+    <p:sldId id="363" r:id="rId23"/>
+    <p:sldId id="361" r:id="rId24"/>
+    <p:sldId id="290" r:id="rId25"/>
+    <p:sldId id="364" r:id="rId26"/>
+    <p:sldId id="365" r:id="rId27"/>
+    <p:sldId id="366" r:id="rId28"/>
+    <p:sldId id="367" r:id="rId29"/>
+    <p:sldId id="368" r:id="rId30"/>
+    <p:sldId id="380" r:id="rId31"/>
+    <p:sldId id="369" r:id="rId32"/>
+    <p:sldId id="371" r:id="rId33"/>
+    <p:sldId id="381" r:id="rId34"/>
+    <p:sldId id="370" r:id="rId35"/>
+    <p:sldId id="287" r:id="rId36"/>
+    <p:sldId id="393" r:id="rId37"/>
+    <p:sldId id="394" r:id="rId38"/>
+    <p:sldId id="395" r:id="rId39"/>
+    <p:sldId id="396" r:id="rId40"/>
+    <p:sldId id="397" r:id="rId41"/>
+    <p:sldId id="435" r:id="rId42"/>
+    <p:sldId id="436" r:id="rId43"/>
+    <p:sldId id="398" r:id="rId44"/>
+    <p:sldId id="509" r:id="rId45"/>
     <p:sldId id="399" r:id="rId46"/>
     <p:sldId id="400" r:id="rId47"/>
     <p:sldId id="401" r:id="rId48"/>
@@ -260,7 +260,7 @@
           <a:p>
             <a:fld id="{8E938536-29D3-49BD-A567-41CAF057586A}" type="datetimeFigureOut">
               <a:rPr lang="en-US" smtClean="0"/>
-              <a:t>9/28/2026</a:t>
+              <a:t>9/30/2026</a:t>
             </a:fld>
             <a:endParaRPr lang="en-US"/>
           </a:p>
@@ -425,7 +425,7 @@
           <a:p>
             <a:fld id="{71559A16-B3AD-4CE2-9A5E-FAAD3C2C27CA}" type="datetimeFigureOut">
               <a:rPr lang="en-US" smtClean="0"/>
-              <a:t>9/28/2026</a:t>
+              <a:t>9/30/2026</a:t>
             </a:fld>
             <a:endParaRPr lang="en-US"/>
           </a:p>
@@ -871,7 +871,7 @@
                   <a:spcPct val="0"/>
                 </a:spcBef>
               </a:pPr>
-              <a:t>21</a:t>
+              <a:t>20</a:t>
             </a:fld>
             <a:endParaRPr lang="en-US" altLang="en-US">
               <a:latin typeface="Arial" panose="020B0604020202020204" pitchFamily="34" charset="0"/>
@@ -1111,7 +1111,7 @@
                   <a:spcPct val="0"/>
                 </a:spcBef>
               </a:pPr>
-              <a:t>22</a:t>
+              <a:t>21</a:t>
             </a:fld>
             <a:endParaRPr lang="en-US" altLang="en-US">
               <a:latin typeface="Arial" panose="020B0604020202020204" pitchFamily="34" charset="0"/>
@@ -1351,7 +1351,7 @@
                   <a:spcPct val="0"/>
                 </a:spcBef>
               </a:pPr>
-              <a:t>23</a:t>
+              <a:t>22</a:t>
             </a:fld>
             <a:endParaRPr lang="en-US" altLang="en-US">
               <a:latin typeface="Arial" panose="020B0604020202020204" pitchFamily="34" charset="0"/>
@@ -1591,7 +1591,7 @@
                   <a:spcPct val="0"/>
                 </a:spcBef>
               </a:pPr>
-              <a:t>25</a:t>
+              <a:t>24</a:t>
             </a:fld>
             <a:endParaRPr lang="en-US" altLang="en-US">
               <a:latin typeface="Arial" panose="020B0604020202020204" pitchFamily="34" charset="0"/>
@@ -1831,7 +1831,7 @@
                   <a:spcPct val="0"/>
                 </a:spcBef>
               </a:pPr>
-              <a:t>34</a:t>
+              <a:t>33</a:t>
             </a:fld>
             <a:endParaRPr lang="en-US" altLang="en-US">
               <a:latin typeface="Arial" panose="020B0604020202020204" pitchFamily="34" charset="0"/>
@@ -2146,7 +2146,7 @@
                 <a:tabLst/>
                 <a:defRPr/>
               </a:pPr>
-              <a:t>39</a:t>
+              <a:t>38</a:t>
             </a:fld>
             <a:endParaRPr kumimoji="0" lang="en-US" altLang="en-US" sz="1200" b="0" i="0" u="none" strike="noStrike" kern="1200" cap="none" spc="0" normalizeH="0" baseline="0" noProof="0">
               <a:ln>
@@ -3284,7 +3284,7 @@
           <a:p>
             <a:fld id="{14C656F1-AD33-45CA-85C7-DC330226D9FE}" type="datetime1">
               <a:rPr lang="en-US" smtClean="0"/>
-              <a:t>9/28/2026</a:t>
+              <a:t>9/30/2026</a:t>
             </a:fld>
             <a:endParaRPr lang="en-US"/>
           </a:p>
@@ -3538,7 +3538,7 @@
             </a:pPr>
             <a:fld id="{EEF94DD4-5043-4A3A-99E2-3B90AB8E4ADF}" type="datetime1">
               <a:rPr lang="en-US" smtClean="0"/>
-              <a:t>9/28/2026</a:t>
+              <a:t>9/30/2026</a:t>
             </a:fld>
             <a:endParaRPr lang="en-US"/>
           </a:p>
@@ -7698,14 +7698,20 @@
             </a:pPr>
             <a:r>
               <a:rPr lang="en-US" altLang="en-US" b="1" dirty="0">
+                <a:solidFill>
+                  <a:schemeClr val="tx1"/>
+                </a:solidFill>
                 <a:cs typeface="Times New Roman" panose="02020603050405020304" pitchFamily="18" charset="0"/>
               </a:rPr>
-              <a:t>Waterfall Software Development </a:t>
+              <a:t>Agile Software Development</a:t>
             </a:r>
           </a:p>
           <a:p>
             <a:pPr lvl="1" algn="just"/>
             <a:endParaRPr lang="en-US" altLang="en-US" dirty="0">
+              <a:solidFill>
+                <a:schemeClr val="tx1"/>
+              </a:solidFill>
               <a:cs typeface="Times New Roman" panose="02020603050405020304" pitchFamily="18" charset="0"/>
             </a:endParaRPr>
           </a:p>
@@ -7713,14 +7719,20 @@
             <a:pPr lvl="1" algn="just"/>
             <a:r>
               <a:rPr lang="en-US" altLang="en-US" dirty="0">
+                <a:solidFill>
+                  <a:schemeClr val="tx1"/>
+                </a:solidFill>
                 <a:cs typeface="Times New Roman" panose="02020603050405020304" pitchFamily="18" charset="0"/>
               </a:rPr>
-              <a:t>Do everything in steps</a:t>
+              <a:t>Do everything in small iterations/cycles</a:t>
             </a:r>
           </a:p>
           <a:p>
             <a:pPr lvl="1" algn="just"/>
             <a:endParaRPr lang="en-US" altLang="en-US" dirty="0">
+              <a:solidFill>
+                <a:schemeClr val="tx1"/>
+              </a:solidFill>
               <a:cs typeface="Times New Roman" panose="02020603050405020304" pitchFamily="18" charset="0"/>
             </a:endParaRPr>
           </a:p>
@@ -7728,14 +7740,83 @@
             <a:pPr lvl="1" algn="just"/>
             <a:r>
               <a:rPr lang="en-US" altLang="en-US" dirty="0">
+                <a:solidFill>
+                  <a:schemeClr val="tx1"/>
+                </a:solidFill>
                 <a:cs typeface="Times New Roman" panose="02020603050405020304" pitchFamily="18" charset="0"/>
               </a:rPr>
-              <a:t>Requirement analysis</a:t>
+              <a:t>Every cycle includes:</a:t>
+            </a:r>
+          </a:p>
+          <a:p>
+            <a:pPr lvl="2" algn="just"/>
+            <a:endParaRPr lang="en-US" altLang="en-US" dirty="0">
+              <a:solidFill>
+                <a:schemeClr val="tx1"/>
+              </a:solidFill>
+              <a:cs typeface="Times New Roman" panose="02020603050405020304" pitchFamily="18" charset="0"/>
+            </a:endParaRPr>
+          </a:p>
+          <a:p>
+            <a:pPr lvl="2" algn="just"/>
+            <a:r>
+              <a:rPr lang="en-US" altLang="en-US" dirty="0">
+                <a:solidFill>
+                  <a:schemeClr val="tx1"/>
+                </a:solidFill>
+                <a:cs typeface="Times New Roman" panose="02020603050405020304" pitchFamily="18" charset="0"/>
+              </a:rPr>
+              <a:t>Requirements analysis (change request)</a:t>
+            </a:r>
+          </a:p>
+          <a:p>
+            <a:pPr lvl="2" algn="just"/>
+            <a:endParaRPr lang="en-US" altLang="en-US" dirty="0">
+              <a:solidFill>
+                <a:schemeClr val="tx1"/>
+              </a:solidFill>
+              <a:cs typeface="Times New Roman" panose="02020603050405020304" pitchFamily="18" charset="0"/>
+            </a:endParaRPr>
+          </a:p>
+          <a:p>
+            <a:pPr lvl="2" algn="just"/>
+            <a:r>
+              <a:rPr lang="en-US" altLang="en-US" dirty="0">
+                <a:solidFill>
+                  <a:schemeClr val="tx1"/>
+                </a:solidFill>
+                <a:cs typeface="Times New Roman" panose="02020603050405020304" pitchFamily="18" charset="0"/>
+              </a:rPr>
+              <a:t>Update design</a:t>
+            </a:r>
+          </a:p>
+          <a:p>
+            <a:pPr lvl="2" algn="just"/>
+            <a:endParaRPr lang="en-US" altLang="en-US" dirty="0">
+              <a:solidFill>
+                <a:schemeClr val="tx1"/>
+              </a:solidFill>
+              <a:cs typeface="Times New Roman" panose="02020603050405020304" pitchFamily="18" charset="0"/>
+            </a:endParaRPr>
+          </a:p>
+          <a:p>
+            <a:pPr lvl="2" algn="just"/>
+            <a:r>
+              <a:rPr lang="en-US" altLang="en-US" dirty="0">
+                <a:solidFill>
+                  <a:schemeClr val="tx1"/>
+                </a:solidFill>
+                <a:cs typeface="Times New Roman" panose="02020603050405020304" pitchFamily="18" charset="0"/>
+              </a:rPr>
+              <a:t>Continue implementation</a:t>
             </a:r>
           </a:p>
           <a:p>
             <a:pPr lvl="1" algn="just"/>
             <a:endParaRPr lang="en-US" altLang="en-US" dirty="0">
+              <a:solidFill>
+                <a:schemeClr val="tx1"/>
+              </a:solidFill>
               <a:cs typeface="Times New Roman" panose="02020603050405020304" pitchFamily="18" charset="0"/>
             </a:endParaRPr>
           </a:p>
@@ -7743,202 +7824,9 @@
             <a:pPr lvl="1" algn="just"/>
             <a:r>
               <a:rPr lang="en-US" altLang="en-US" dirty="0">
-                <a:cs typeface="Times New Roman" panose="02020603050405020304" pitchFamily="18" charset="0"/>
-              </a:rPr>
-              <a:t>Design</a:t>
-            </a:r>
-          </a:p>
-          <a:p>
-            <a:pPr lvl="1" algn="just"/>
-            <a:endParaRPr lang="en-US" altLang="en-US" dirty="0">
-              <a:cs typeface="Times New Roman" panose="02020603050405020304" pitchFamily="18" charset="0"/>
-            </a:endParaRPr>
-          </a:p>
-          <a:p>
-            <a:pPr lvl="1" algn="just"/>
-            <a:r>
-              <a:rPr lang="en-US" altLang="en-US" dirty="0">
-                <a:cs typeface="Times New Roman" panose="02020603050405020304" pitchFamily="18" charset="0"/>
-              </a:rPr>
-              <a:t>Implementation</a:t>
-            </a:r>
-          </a:p>
-          <a:p>
-            <a:pPr lvl="1" algn="just"/>
-            <a:endParaRPr lang="en-US" altLang="en-US" dirty="0">
-              <a:cs typeface="Times New Roman" panose="02020603050405020304" pitchFamily="18" charset="0"/>
-            </a:endParaRPr>
-          </a:p>
-          <a:p>
-            <a:pPr lvl="1" algn="just"/>
-            <a:r>
-              <a:rPr lang="en-US" altLang="en-US" dirty="0">
-                <a:cs typeface="Times New Roman" panose="02020603050405020304" pitchFamily="18" charset="0"/>
-              </a:rPr>
-              <a:t>Done</a:t>
-            </a:r>
-          </a:p>
-          <a:p>
-            <a:pPr eaLnBrk="1" hangingPunct="1">
-              <a:lnSpc>
-                <a:spcPct val="90000"/>
-              </a:lnSpc>
-            </a:pPr>
-            <a:endParaRPr lang="en-US" altLang="en-US" dirty="0"/>
-          </a:p>
-        </p:txBody>
-      </p:sp>
-    </p:spTree>
-    <p:extLst>
-      <p:ext uri="{BB962C8B-B14F-4D97-AF65-F5344CB8AC3E}">
-        <p14:creationId xmlns:p14="http://schemas.microsoft.com/office/powerpoint/2010/main" val="1740188958"/>
-      </p:ext>
-    </p:extLst>
-  </p:cSld>
-  <p:clrMapOvr>
-    <a:masterClrMapping/>
-  </p:clrMapOvr>
-  <p:transition/>
-</p:sld>
-</file>
-
-<file path=ppt/slides/slide11.xml><?xml version="1.0" encoding="utf-8"?>
-<p:sld xmlns:a="http://schemas.openxmlformats.org/drawingml/2006/main" xmlns:r="http://schemas.openxmlformats.org/officeDocument/2006/relationships" xmlns:p="http://schemas.openxmlformats.org/presentationml/2006/main">
-  <p:cSld>
-    <p:spTree>
-      <p:nvGrpSpPr>
-        <p:cNvPr id="1" name=""/>
-        <p:cNvGrpSpPr/>
-        <p:nvPr/>
-      </p:nvGrpSpPr>
-      <p:grpSpPr>
-        <a:xfrm>
-          <a:off x="0" y="0"/>
-          <a:ext cx="0" cy="0"/>
-          <a:chOff x="0" y="0"/>
-          <a:chExt cx="0" cy="0"/>
-        </a:xfrm>
-      </p:grpSpPr>
-      <p:sp>
-        <p:nvSpPr>
-          <p:cNvPr id="26627" name="Rectangle 3"/>
-          <p:cNvSpPr>
-            <a:spLocks noGrp="1" noChangeArrowheads="1"/>
-          </p:cNvSpPr>
-          <p:nvPr>
-            <p:ph idx="1"/>
-          </p:nvPr>
-        </p:nvSpPr>
-        <p:spPr>
-          <a:xfrm>
-            <a:off x="1301469" y="1092424"/>
-            <a:ext cx="7967958" cy="5348835"/>
-          </a:xfrm>
-        </p:spPr>
-        <p:txBody>
-          <a:bodyPr>
-            <a:normAutofit/>
-          </a:bodyPr>
-          <a:lstStyle/>
-          <a:p>
-            <a:pPr marL="457200" lvl="1" indent="0" algn="just" eaLnBrk="1" hangingPunct="1">
-              <a:lnSpc>
-                <a:spcPct val="90000"/>
-              </a:lnSpc>
-              <a:buNone/>
-            </a:pPr>
-            <a:r>
-              <a:rPr lang="en-US" altLang="en-US" b="1" dirty="0">
-                <a:cs typeface="Times New Roman" panose="02020603050405020304" pitchFamily="18" charset="0"/>
-              </a:rPr>
-              <a:t>Agile Software Development</a:t>
-            </a:r>
-          </a:p>
-          <a:p>
-            <a:pPr lvl="1" algn="just"/>
-            <a:endParaRPr lang="en-US" altLang="en-US" dirty="0">
-              <a:cs typeface="Times New Roman" panose="02020603050405020304" pitchFamily="18" charset="0"/>
-            </a:endParaRPr>
-          </a:p>
-          <a:p>
-            <a:pPr lvl="1" algn="just"/>
-            <a:r>
-              <a:rPr lang="en-US" altLang="en-US" dirty="0">
-                <a:cs typeface="Times New Roman" panose="02020603050405020304" pitchFamily="18" charset="0"/>
-              </a:rPr>
-              <a:t>Do everything in small iterations/cycles</a:t>
-            </a:r>
-          </a:p>
-          <a:p>
-            <a:pPr lvl="1" algn="just"/>
-            <a:endParaRPr lang="en-US" altLang="en-US" dirty="0">
-              <a:cs typeface="Times New Roman" panose="02020603050405020304" pitchFamily="18" charset="0"/>
-            </a:endParaRPr>
-          </a:p>
-          <a:p>
-            <a:pPr lvl="1" algn="just"/>
-            <a:r>
-              <a:rPr lang="en-US" altLang="en-US" dirty="0">
-                <a:cs typeface="Times New Roman" panose="02020603050405020304" pitchFamily="18" charset="0"/>
-              </a:rPr>
-              <a:t>Every cycle includes:</a:t>
-            </a:r>
-          </a:p>
-          <a:p>
-            <a:pPr lvl="2" algn="just"/>
-            <a:endParaRPr lang="en-US" altLang="en-US" dirty="0">
-              <a:cs typeface="Times New Roman" panose="02020603050405020304" pitchFamily="18" charset="0"/>
-            </a:endParaRPr>
-          </a:p>
-          <a:p>
-            <a:pPr lvl="2" algn="just"/>
-            <a:r>
-              <a:rPr lang="en-US" altLang="en-US" dirty="0">
-                <a:cs typeface="Times New Roman" panose="02020603050405020304" pitchFamily="18" charset="0"/>
-              </a:rPr>
-              <a:t>Requirements analysis (change request)</a:t>
-            </a:r>
-          </a:p>
-          <a:p>
-            <a:pPr lvl="2" algn="just"/>
-            <a:endParaRPr lang="en-US" altLang="en-US" dirty="0">
-              <a:cs typeface="Times New Roman" panose="02020603050405020304" pitchFamily="18" charset="0"/>
-            </a:endParaRPr>
-          </a:p>
-          <a:p>
-            <a:pPr lvl="2" algn="just"/>
-            <a:r>
-              <a:rPr lang="en-US" altLang="en-US" dirty="0">
-                <a:cs typeface="Times New Roman" panose="02020603050405020304" pitchFamily="18" charset="0"/>
-              </a:rPr>
-              <a:t>Update design</a:t>
-            </a:r>
-          </a:p>
-          <a:p>
-            <a:pPr lvl="2" algn="just"/>
-            <a:endParaRPr lang="en-US" altLang="en-US" dirty="0">
-              <a:cs typeface="Times New Roman" panose="02020603050405020304" pitchFamily="18" charset="0"/>
-            </a:endParaRPr>
-          </a:p>
-          <a:p>
-            <a:pPr lvl="2" algn="just"/>
-            <a:r>
-              <a:rPr lang="en-US" altLang="en-US" dirty="0">
-                <a:cs typeface="Times New Roman" panose="02020603050405020304" pitchFamily="18" charset="0"/>
-              </a:rPr>
-              <a:t>Continue implementation</a:t>
-            </a:r>
-          </a:p>
-          <a:p>
-            <a:pPr lvl="1" algn="just"/>
-            <a:endParaRPr lang="en-US" altLang="en-US" dirty="0">
-              <a:cs typeface="Times New Roman" panose="02020603050405020304" pitchFamily="18" charset="0"/>
-            </a:endParaRPr>
-          </a:p>
-          <a:p>
-            <a:pPr lvl="1" algn="just"/>
-            <a:r>
-              <a:rPr lang="en-US" altLang="en-US" dirty="0">
+                <a:solidFill>
+                  <a:schemeClr val="tx1"/>
+                </a:solidFill>
                 <a:cs typeface="Times New Roman" panose="02020603050405020304" pitchFamily="18" charset="0"/>
               </a:rPr>
               <a:t>Done</a:t>
@@ -7974,7 +7862,7 @@
 </p:sld>
 </file>
 
-<file path=ppt/slides/slide12.xml><?xml version="1.0" encoding="utf-8"?>
+<file path=ppt/slides/slide11.xml><?xml version="1.0" encoding="utf-8"?>
 <p:sld xmlns:a="http://schemas.openxmlformats.org/drawingml/2006/main" xmlns:r="http://schemas.openxmlformats.org/officeDocument/2006/relationships" xmlns:p="http://schemas.openxmlformats.org/presentationml/2006/main">
   <p:cSld>
     <p:spTree>
@@ -8215,7 +8103,7 @@
 </p:sld>
 </file>
 
-<file path=ppt/slides/slide13.xml><?xml version="1.0" encoding="utf-8"?>
+<file path=ppt/slides/slide12.xml><?xml version="1.0" encoding="utf-8"?>
 <p:sld xmlns:a="http://schemas.openxmlformats.org/drawingml/2006/main" xmlns:r="http://schemas.openxmlformats.org/officeDocument/2006/relationships" xmlns:p="http://schemas.openxmlformats.org/presentationml/2006/main">
   <p:cSld>
     <p:spTree>
@@ -8367,6 +8255,9 @@
             </a:pPr>
             <a:r>
               <a:rPr lang="en-US" altLang="en-US" dirty="0">
+                <a:solidFill>
+                  <a:schemeClr val="tx1"/>
+                </a:solidFill>
                 <a:cs typeface="Times New Roman" panose="02020603050405020304" pitchFamily="18" charset="0"/>
               </a:rPr>
               <a:t>Structuring a complex system using OO decomposition.</a:t>
@@ -8380,6 +8271,9 @@
             </a:pPr>
             <a:r>
               <a:rPr lang="en-US" altLang="en-US" dirty="0">
+                <a:solidFill>
+                  <a:schemeClr val="tx1"/>
+                </a:solidFill>
                 <a:cs typeface="Times New Roman" panose="02020603050405020304" pitchFamily="18" charset="0"/>
               </a:rPr>
               <a:t>Express in different models (state, class, sequence, …)</a:t>
@@ -8422,6 +8316,9 @@
             </a:pPr>
             <a:r>
               <a:rPr lang="en-US" altLang="en-US" dirty="0">
+                <a:solidFill>
+                  <a:schemeClr val="tx1"/>
+                </a:solidFill>
                 <a:cs typeface="Times New Roman" panose="02020603050405020304" pitchFamily="18" charset="0"/>
               </a:rPr>
               <a:t>Implementation using classes and objects.</a:t>
@@ -8435,6 +8332,9 @@
             </a:pPr>
             <a:r>
               <a:rPr lang="en-US" altLang="en-US" dirty="0">
+                <a:solidFill>
+                  <a:schemeClr val="tx1"/>
+                </a:solidFill>
                 <a:cs typeface="Times New Roman" panose="02020603050405020304" pitchFamily="18" charset="0"/>
               </a:rPr>
               <a:t>Objects with interface + hidden local state.</a:t>
@@ -8448,6 +8348,9 @@
             </a:pPr>
             <a:r>
               <a:rPr lang="en-US" altLang="en-US" dirty="0">
+                <a:solidFill>
+                  <a:schemeClr val="tx1"/>
+                </a:solidFill>
                 <a:cs typeface="Times New Roman" panose="02020603050405020304" pitchFamily="18" charset="0"/>
               </a:rPr>
               <a:t>Objects have types. </a:t>
@@ -8461,17 +8364,13 @@
             </a:pPr>
             <a:r>
               <a:rPr lang="en-US" altLang="en-US" dirty="0">
+                <a:solidFill>
+                  <a:schemeClr val="tx1"/>
+                </a:solidFill>
                 <a:cs typeface="Times New Roman" panose="02020603050405020304" pitchFamily="18" charset="0"/>
               </a:rPr>
               <a:t>Types are arranged in hierarchies</a:t>
             </a:r>
-          </a:p>
-          <a:p>
-            <a:pPr lvl="1" algn="just" eaLnBrk="1" hangingPunct="1">
-              <a:lnSpc>
-                <a:spcPct val="90000"/>
-              </a:lnSpc>
-            </a:pPr>
             <a:endParaRPr lang="en-US" altLang="en-US" dirty="0">
               <a:cs typeface="Times New Roman" panose="02020603050405020304" pitchFamily="18" charset="0"/>
             </a:endParaRPr>
@@ -8510,7 +8409,7 @@
 </p:sld>
 </file>
 
-<file path=ppt/slides/slide14.xml><?xml version="1.0" encoding="utf-8"?>
+<file path=ppt/slides/slide13.xml><?xml version="1.0" encoding="utf-8"?>
 <p:sld xmlns:a="http://schemas.openxmlformats.org/drawingml/2006/main" xmlns:r="http://schemas.openxmlformats.org/officeDocument/2006/relationships" xmlns:p="http://schemas.openxmlformats.org/presentationml/2006/main">
   <p:cSld>
     <p:spTree>
@@ -8659,7 +8558,7 @@
 </p:sld>
 </file>
 
-<file path=ppt/slides/slide15.xml><?xml version="1.0" encoding="utf-8"?>
+<file path=ppt/slides/slide14.xml><?xml version="1.0" encoding="utf-8"?>
 <p:sld xmlns:a="http://schemas.openxmlformats.org/drawingml/2006/main" xmlns:r="http://schemas.openxmlformats.org/officeDocument/2006/relationships" xmlns:p="http://schemas.openxmlformats.org/presentationml/2006/main">
   <p:cSld>
     <p:spTree>
@@ -8838,7 +8737,7 @@
 </p:sld>
 </file>
 
-<file path=ppt/slides/slide16.xml><?xml version="1.0" encoding="utf-8"?>
+<file path=ppt/slides/slide15.xml><?xml version="1.0" encoding="utf-8"?>
 <p:sld xmlns:a="http://schemas.openxmlformats.org/drawingml/2006/main" xmlns:r="http://schemas.openxmlformats.org/officeDocument/2006/relationships" xmlns:p="http://schemas.openxmlformats.org/presentationml/2006/main">
   <p:cSld>
     <p:spTree>
@@ -8988,7 +8887,7 @@
 </p:sld>
 </file>
 
-<file path=ppt/slides/slide17.xml><?xml version="1.0" encoding="utf-8"?>
+<file path=ppt/slides/slide16.xml><?xml version="1.0" encoding="utf-8"?>
 <p:sld xmlns:a="http://schemas.openxmlformats.org/drawingml/2006/main" xmlns:r="http://schemas.openxmlformats.org/officeDocument/2006/relationships" xmlns:p="http://schemas.openxmlformats.org/presentationml/2006/main">
   <p:cSld>
     <p:spTree>
@@ -9166,7 +9065,7 @@
 </p:sld>
 </file>
 
-<file path=ppt/slides/slide18.xml><?xml version="1.0" encoding="utf-8"?>
+<file path=ppt/slides/slide17.xml><?xml version="1.0" encoding="utf-8"?>
 <p:sld xmlns:a="http://schemas.openxmlformats.org/drawingml/2006/main" xmlns:r="http://schemas.openxmlformats.org/officeDocument/2006/relationships" xmlns:p="http://schemas.openxmlformats.org/presentationml/2006/main">
   <p:cSld>
     <p:spTree>
@@ -9305,7 +9204,7 @@
 </p:sld>
 </file>
 
-<file path=ppt/slides/slide19.xml><?xml version="1.0" encoding="utf-8"?>
+<file path=ppt/slides/slide18.xml><?xml version="1.0" encoding="utf-8"?>
 <p:sld xmlns:a="http://schemas.openxmlformats.org/drawingml/2006/main" xmlns:r="http://schemas.openxmlformats.org/officeDocument/2006/relationships" xmlns:p="http://schemas.openxmlformats.org/presentationml/2006/main">
   <p:cSld>
     <p:spTree>
@@ -9433,6 +9332,254 @@
 </p:sld>
 </file>
 
+<file path=ppt/slides/slide19.xml><?xml version="1.0" encoding="utf-8"?>
+<p:sld xmlns:a="http://schemas.openxmlformats.org/drawingml/2006/main" xmlns:r="http://schemas.openxmlformats.org/officeDocument/2006/relationships" xmlns:p="http://schemas.openxmlformats.org/presentationml/2006/main">
+  <p:cSld>
+    <p:spTree>
+      <p:nvGrpSpPr>
+        <p:cNvPr id="1" name=""/>
+        <p:cNvGrpSpPr/>
+        <p:nvPr/>
+      </p:nvGrpSpPr>
+      <p:grpSpPr>
+        <a:xfrm>
+          <a:off x="0" y="0"/>
+          <a:ext cx="0" cy="0"/>
+          <a:chOff x="0" y="0"/>
+          <a:chExt cx="0" cy="0"/>
+        </a:xfrm>
+      </p:grpSpPr>
+      <p:sp>
+        <p:nvSpPr>
+          <p:cNvPr id="2" name="Title 1"/>
+          <p:cNvSpPr>
+            <a:spLocks noGrp="1"/>
+          </p:cNvSpPr>
+          <p:nvPr>
+            <p:ph type="ctrTitle"/>
+          </p:nvPr>
+        </p:nvSpPr>
+        <p:spPr/>
+        <p:txBody>
+          <a:bodyPr rtlCol="0">
+            <a:normAutofit/>
+          </a:bodyPr>
+          <a:lstStyle/>
+          <a:p>
+            <a:pPr>
+              <a:defRPr/>
+            </a:pPr>
+            <a:r>
+              <a:rPr lang="en-US" dirty="0"/>
+              <a:t>Object-Oriented </a:t>
+            </a:r>
+            <a:br>
+              <a:rPr lang="en-US" dirty="0"/>
+            </a:br>
+            <a:r>
+              <a:rPr lang="en-US" dirty="0"/>
+              <a:t>Bank Account Example</a:t>
+            </a:r>
+          </a:p>
+        </p:txBody>
+      </p:sp>
+      <p:sp>
+        <p:nvSpPr>
+          <p:cNvPr id="5123" name="Slide Number Placeholder 3"/>
+          <p:cNvSpPr>
+            <a:spLocks noGrp="1"/>
+          </p:cNvSpPr>
+          <p:nvPr>
+            <p:ph type="sldNum" sz="quarter" idx="4294967295"/>
+          </p:nvPr>
+        </p:nvSpPr>
+        <p:spPr bwMode="auto">
+          <a:noFill/>
+          <a:extLst>
+            <a:ext uri="{909E8E84-426E-40DD-AFC4-6F175D3DCCD1}">
+              <a14:hiddenFill xmlns:a14="http://schemas.microsoft.com/office/drawing/2010/main">
+                <a:solidFill>
+                  <a:srgbClr val="FFFFFF"/>
+                </a:solidFill>
+              </a14:hiddenFill>
+            </a:ext>
+            <a:ext uri="{91240B29-F687-4F45-9708-019B960494DF}">
+              <a14:hiddenLine xmlns:a14="http://schemas.microsoft.com/office/drawing/2010/main" w="9525">
+                <a:solidFill>
+                  <a:srgbClr val="000000"/>
+                </a:solidFill>
+                <a:miter lim="800000"/>
+                <a:headEnd/>
+                <a:tailEnd/>
+              </a14:hiddenLine>
+            </a:ext>
+          </a:extLst>
+        </p:spPr>
+        <p:txBody>
+          <a:bodyPr/>
+          <a:lstStyle>
+            <a:lvl1pPr>
+              <a:spcBef>
+                <a:spcPct val="20000"/>
+              </a:spcBef>
+              <a:buFont typeface="Arial" panose="020B0604020202020204" pitchFamily="34" charset="0"/>
+              <a:buChar char="•"/>
+              <a:defRPr sz="3200">
+                <a:solidFill>
+                  <a:schemeClr val="tx1"/>
+                </a:solidFill>
+                <a:latin typeface="Calibri" panose="020F0502020204030204" pitchFamily="34" charset="0"/>
+              </a:defRPr>
+            </a:lvl1pPr>
+            <a:lvl2pPr marL="742950" indent="-285750">
+              <a:spcBef>
+                <a:spcPct val="20000"/>
+              </a:spcBef>
+              <a:buFont typeface="Arial" panose="020B0604020202020204" pitchFamily="34" charset="0"/>
+              <a:buChar char="–"/>
+              <a:defRPr sz="2800">
+                <a:solidFill>
+                  <a:schemeClr val="tx1"/>
+                </a:solidFill>
+                <a:latin typeface="Calibri" panose="020F0502020204030204" pitchFamily="34" charset="0"/>
+              </a:defRPr>
+            </a:lvl2pPr>
+            <a:lvl3pPr marL="1143000" indent="-228600">
+              <a:spcBef>
+                <a:spcPct val="20000"/>
+              </a:spcBef>
+              <a:buFont typeface="Arial" panose="020B0604020202020204" pitchFamily="34" charset="0"/>
+              <a:buChar char="•"/>
+              <a:defRPr sz="2400">
+                <a:solidFill>
+                  <a:schemeClr val="tx1"/>
+                </a:solidFill>
+                <a:latin typeface="Calibri" panose="020F0502020204030204" pitchFamily="34" charset="0"/>
+              </a:defRPr>
+            </a:lvl3pPr>
+            <a:lvl4pPr marL="1600200" indent="-228600">
+              <a:spcBef>
+                <a:spcPct val="20000"/>
+              </a:spcBef>
+              <a:buFont typeface="Arial" panose="020B0604020202020204" pitchFamily="34" charset="0"/>
+              <a:buChar char="–"/>
+              <a:defRPr sz="2000">
+                <a:solidFill>
+                  <a:schemeClr val="tx1"/>
+                </a:solidFill>
+                <a:latin typeface="Calibri" panose="020F0502020204030204" pitchFamily="34" charset="0"/>
+              </a:defRPr>
+            </a:lvl4pPr>
+            <a:lvl5pPr marL="2057400" indent="-228600">
+              <a:spcBef>
+                <a:spcPct val="20000"/>
+              </a:spcBef>
+              <a:buFont typeface="Arial" panose="020B0604020202020204" pitchFamily="34" charset="0"/>
+              <a:buChar char="»"/>
+              <a:defRPr sz="2000">
+                <a:solidFill>
+                  <a:schemeClr val="tx1"/>
+                </a:solidFill>
+                <a:latin typeface="Calibri" panose="020F0502020204030204" pitchFamily="34" charset="0"/>
+              </a:defRPr>
+            </a:lvl5pPr>
+            <a:lvl6pPr marL="2514600" indent="-228600" eaLnBrk="0" fontAlgn="base" hangingPunct="0">
+              <a:spcBef>
+                <a:spcPct val="20000"/>
+              </a:spcBef>
+              <a:spcAft>
+                <a:spcPct val="0"/>
+              </a:spcAft>
+              <a:buFont typeface="Arial" panose="020B0604020202020204" pitchFamily="34" charset="0"/>
+              <a:buChar char="»"/>
+              <a:defRPr sz="2000">
+                <a:solidFill>
+                  <a:schemeClr val="tx1"/>
+                </a:solidFill>
+                <a:latin typeface="Calibri" panose="020F0502020204030204" pitchFamily="34" charset="0"/>
+              </a:defRPr>
+            </a:lvl6pPr>
+            <a:lvl7pPr marL="2971800" indent="-228600" eaLnBrk="0" fontAlgn="base" hangingPunct="0">
+              <a:spcBef>
+                <a:spcPct val="20000"/>
+              </a:spcBef>
+              <a:spcAft>
+                <a:spcPct val="0"/>
+              </a:spcAft>
+              <a:buFont typeface="Arial" panose="020B0604020202020204" pitchFamily="34" charset="0"/>
+              <a:buChar char="»"/>
+              <a:defRPr sz="2000">
+                <a:solidFill>
+                  <a:schemeClr val="tx1"/>
+                </a:solidFill>
+                <a:latin typeface="Calibri" panose="020F0502020204030204" pitchFamily="34" charset="0"/>
+              </a:defRPr>
+            </a:lvl7pPr>
+            <a:lvl8pPr marL="3429000" indent="-228600" eaLnBrk="0" fontAlgn="base" hangingPunct="0">
+              <a:spcBef>
+                <a:spcPct val="20000"/>
+              </a:spcBef>
+              <a:spcAft>
+                <a:spcPct val="0"/>
+              </a:spcAft>
+              <a:buFont typeface="Arial" panose="020B0604020202020204" pitchFamily="34" charset="0"/>
+              <a:buChar char="»"/>
+              <a:defRPr sz="2000">
+                <a:solidFill>
+                  <a:schemeClr val="tx1"/>
+                </a:solidFill>
+                <a:latin typeface="Calibri" panose="020F0502020204030204" pitchFamily="34" charset="0"/>
+              </a:defRPr>
+            </a:lvl8pPr>
+            <a:lvl9pPr marL="3886200" indent="-228600" eaLnBrk="0" fontAlgn="base" hangingPunct="0">
+              <a:spcBef>
+                <a:spcPct val="20000"/>
+              </a:spcBef>
+              <a:spcAft>
+                <a:spcPct val="0"/>
+              </a:spcAft>
+              <a:buFont typeface="Arial" panose="020B0604020202020204" pitchFamily="34" charset="0"/>
+              <a:buChar char="»"/>
+              <a:defRPr sz="2000">
+                <a:solidFill>
+                  <a:schemeClr val="tx1"/>
+                </a:solidFill>
+                <a:latin typeface="Calibri" panose="020F0502020204030204" pitchFamily="34" charset="0"/>
+              </a:defRPr>
+            </a:lvl9pPr>
+          </a:lstStyle>
+          <a:p>
+            <a:pPr>
+              <a:spcBef>
+                <a:spcPct val="0"/>
+              </a:spcBef>
+              <a:buFontTx/>
+              <a:buNone/>
+            </a:pPr>
+            <a:r>
+              <a:rPr lang="en-US" altLang="en-US" sz="1200" dirty="0">
+                <a:solidFill>
+                  <a:srgbClr val="898989"/>
+                </a:solidFill>
+              </a:rPr>
+              <a:t> </a:t>
+            </a:r>
+          </a:p>
+        </p:txBody>
+      </p:sp>
+    </p:spTree>
+    <p:extLst>
+      <p:ext uri="{BB962C8B-B14F-4D97-AF65-F5344CB8AC3E}">
+        <p14:creationId xmlns:p14="http://schemas.microsoft.com/office/powerpoint/2010/main" val="1735191139"/>
+      </p:ext>
+    </p:extLst>
+  </p:cSld>
+  <p:clrMapOvr>
+    <a:masterClrMapping/>
+  </p:clrMapOvr>
+</p:sld>
+</file>
+
 <file path=ppt/slides/slide2.xml><?xml version="1.0" encoding="utf-8"?>
 <p:sld xmlns:a="http://schemas.openxmlformats.org/drawingml/2006/main" xmlns:r="http://schemas.openxmlformats.org/officeDocument/2006/relationships" xmlns:p="http://schemas.openxmlformats.org/presentationml/2006/main">
   <p:cSld>
@@ -9534,254 +9681,6 @@
       </p:grpSpPr>
       <p:sp>
         <p:nvSpPr>
-          <p:cNvPr id="2" name="Title 1"/>
-          <p:cNvSpPr>
-            <a:spLocks noGrp="1"/>
-          </p:cNvSpPr>
-          <p:nvPr>
-            <p:ph type="ctrTitle"/>
-          </p:nvPr>
-        </p:nvSpPr>
-        <p:spPr/>
-        <p:txBody>
-          <a:bodyPr rtlCol="0">
-            <a:normAutofit/>
-          </a:bodyPr>
-          <a:lstStyle/>
-          <a:p>
-            <a:pPr>
-              <a:defRPr/>
-            </a:pPr>
-            <a:r>
-              <a:rPr lang="en-US" dirty="0"/>
-              <a:t>Object-Oriented </a:t>
-            </a:r>
-            <a:br>
-              <a:rPr lang="en-US" dirty="0"/>
-            </a:br>
-            <a:r>
-              <a:rPr lang="en-US" dirty="0"/>
-              <a:t>Bank Account Example</a:t>
-            </a:r>
-          </a:p>
-        </p:txBody>
-      </p:sp>
-      <p:sp>
-        <p:nvSpPr>
-          <p:cNvPr id="5123" name="Slide Number Placeholder 3"/>
-          <p:cNvSpPr>
-            <a:spLocks noGrp="1"/>
-          </p:cNvSpPr>
-          <p:nvPr>
-            <p:ph type="sldNum" sz="quarter" idx="4294967295"/>
-          </p:nvPr>
-        </p:nvSpPr>
-        <p:spPr bwMode="auto">
-          <a:noFill/>
-          <a:extLst>
-            <a:ext uri="{909E8E84-426E-40DD-AFC4-6F175D3DCCD1}">
-              <a14:hiddenFill xmlns:a14="http://schemas.microsoft.com/office/drawing/2010/main">
-                <a:solidFill>
-                  <a:srgbClr val="FFFFFF"/>
-                </a:solidFill>
-              </a14:hiddenFill>
-            </a:ext>
-            <a:ext uri="{91240B29-F687-4F45-9708-019B960494DF}">
-              <a14:hiddenLine xmlns:a14="http://schemas.microsoft.com/office/drawing/2010/main" w="9525">
-                <a:solidFill>
-                  <a:srgbClr val="000000"/>
-                </a:solidFill>
-                <a:miter lim="800000"/>
-                <a:headEnd/>
-                <a:tailEnd/>
-              </a14:hiddenLine>
-            </a:ext>
-          </a:extLst>
-        </p:spPr>
-        <p:txBody>
-          <a:bodyPr/>
-          <a:lstStyle>
-            <a:lvl1pPr>
-              <a:spcBef>
-                <a:spcPct val="20000"/>
-              </a:spcBef>
-              <a:buFont typeface="Arial" panose="020B0604020202020204" pitchFamily="34" charset="0"/>
-              <a:buChar char="•"/>
-              <a:defRPr sz="3200">
-                <a:solidFill>
-                  <a:schemeClr val="tx1"/>
-                </a:solidFill>
-                <a:latin typeface="Calibri" panose="020F0502020204030204" pitchFamily="34" charset="0"/>
-              </a:defRPr>
-            </a:lvl1pPr>
-            <a:lvl2pPr marL="742950" indent="-285750">
-              <a:spcBef>
-                <a:spcPct val="20000"/>
-              </a:spcBef>
-              <a:buFont typeface="Arial" panose="020B0604020202020204" pitchFamily="34" charset="0"/>
-              <a:buChar char="–"/>
-              <a:defRPr sz="2800">
-                <a:solidFill>
-                  <a:schemeClr val="tx1"/>
-                </a:solidFill>
-                <a:latin typeface="Calibri" panose="020F0502020204030204" pitchFamily="34" charset="0"/>
-              </a:defRPr>
-            </a:lvl2pPr>
-            <a:lvl3pPr marL="1143000" indent="-228600">
-              <a:spcBef>
-                <a:spcPct val="20000"/>
-              </a:spcBef>
-              <a:buFont typeface="Arial" panose="020B0604020202020204" pitchFamily="34" charset="0"/>
-              <a:buChar char="•"/>
-              <a:defRPr sz="2400">
-                <a:solidFill>
-                  <a:schemeClr val="tx1"/>
-                </a:solidFill>
-                <a:latin typeface="Calibri" panose="020F0502020204030204" pitchFamily="34" charset="0"/>
-              </a:defRPr>
-            </a:lvl3pPr>
-            <a:lvl4pPr marL="1600200" indent="-228600">
-              <a:spcBef>
-                <a:spcPct val="20000"/>
-              </a:spcBef>
-              <a:buFont typeface="Arial" panose="020B0604020202020204" pitchFamily="34" charset="0"/>
-              <a:buChar char="–"/>
-              <a:defRPr sz="2000">
-                <a:solidFill>
-                  <a:schemeClr val="tx1"/>
-                </a:solidFill>
-                <a:latin typeface="Calibri" panose="020F0502020204030204" pitchFamily="34" charset="0"/>
-              </a:defRPr>
-            </a:lvl4pPr>
-            <a:lvl5pPr marL="2057400" indent="-228600">
-              <a:spcBef>
-                <a:spcPct val="20000"/>
-              </a:spcBef>
-              <a:buFont typeface="Arial" panose="020B0604020202020204" pitchFamily="34" charset="0"/>
-              <a:buChar char="»"/>
-              <a:defRPr sz="2000">
-                <a:solidFill>
-                  <a:schemeClr val="tx1"/>
-                </a:solidFill>
-                <a:latin typeface="Calibri" panose="020F0502020204030204" pitchFamily="34" charset="0"/>
-              </a:defRPr>
-            </a:lvl5pPr>
-            <a:lvl6pPr marL="2514600" indent="-228600" eaLnBrk="0" fontAlgn="base" hangingPunct="0">
-              <a:spcBef>
-                <a:spcPct val="20000"/>
-              </a:spcBef>
-              <a:spcAft>
-                <a:spcPct val="0"/>
-              </a:spcAft>
-              <a:buFont typeface="Arial" panose="020B0604020202020204" pitchFamily="34" charset="0"/>
-              <a:buChar char="»"/>
-              <a:defRPr sz="2000">
-                <a:solidFill>
-                  <a:schemeClr val="tx1"/>
-                </a:solidFill>
-                <a:latin typeface="Calibri" panose="020F0502020204030204" pitchFamily="34" charset="0"/>
-              </a:defRPr>
-            </a:lvl6pPr>
-            <a:lvl7pPr marL="2971800" indent="-228600" eaLnBrk="0" fontAlgn="base" hangingPunct="0">
-              <a:spcBef>
-                <a:spcPct val="20000"/>
-              </a:spcBef>
-              <a:spcAft>
-                <a:spcPct val="0"/>
-              </a:spcAft>
-              <a:buFont typeface="Arial" panose="020B0604020202020204" pitchFamily="34" charset="0"/>
-              <a:buChar char="»"/>
-              <a:defRPr sz="2000">
-                <a:solidFill>
-                  <a:schemeClr val="tx1"/>
-                </a:solidFill>
-                <a:latin typeface="Calibri" panose="020F0502020204030204" pitchFamily="34" charset="0"/>
-              </a:defRPr>
-            </a:lvl7pPr>
-            <a:lvl8pPr marL="3429000" indent="-228600" eaLnBrk="0" fontAlgn="base" hangingPunct="0">
-              <a:spcBef>
-                <a:spcPct val="20000"/>
-              </a:spcBef>
-              <a:spcAft>
-                <a:spcPct val="0"/>
-              </a:spcAft>
-              <a:buFont typeface="Arial" panose="020B0604020202020204" pitchFamily="34" charset="0"/>
-              <a:buChar char="»"/>
-              <a:defRPr sz="2000">
-                <a:solidFill>
-                  <a:schemeClr val="tx1"/>
-                </a:solidFill>
-                <a:latin typeface="Calibri" panose="020F0502020204030204" pitchFamily="34" charset="0"/>
-              </a:defRPr>
-            </a:lvl8pPr>
-            <a:lvl9pPr marL="3886200" indent="-228600" eaLnBrk="0" fontAlgn="base" hangingPunct="0">
-              <a:spcBef>
-                <a:spcPct val="20000"/>
-              </a:spcBef>
-              <a:spcAft>
-                <a:spcPct val="0"/>
-              </a:spcAft>
-              <a:buFont typeface="Arial" panose="020B0604020202020204" pitchFamily="34" charset="0"/>
-              <a:buChar char="»"/>
-              <a:defRPr sz="2000">
-                <a:solidFill>
-                  <a:schemeClr val="tx1"/>
-                </a:solidFill>
-                <a:latin typeface="Calibri" panose="020F0502020204030204" pitchFamily="34" charset="0"/>
-              </a:defRPr>
-            </a:lvl9pPr>
-          </a:lstStyle>
-          <a:p>
-            <a:pPr>
-              <a:spcBef>
-                <a:spcPct val="0"/>
-              </a:spcBef>
-              <a:buFontTx/>
-              <a:buNone/>
-            </a:pPr>
-            <a:r>
-              <a:rPr lang="en-US" altLang="en-US" sz="1200" dirty="0">
-                <a:solidFill>
-                  <a:srgbClr val="898989"/>
-                </a:solidFill>
-              </a:rPr>
-              <a:t> </a:t>
-            </a:r>
-          </a:p>
-        </p:txBody>
-      </p:sp>
-    </p:spTree>
-    <p:extLst>
-      <p:ext uri="{BB962C8B-B14F-4D97-AF65-F5344CB8AC3E}">
-        <p14:creationId xmlns:p14="http://schemas.microsoft.com/office/powerpoint/2010/main" val="1735191139"/>
-      </p:ext>
-    </p:extLst>
-  </p:cSld>
-  <p:clrMapOvr>
-    <a:masterClrMapping/>
-  </p:clrMapOvr>
-</p:sld>
-</file>
-
-<file path=ppt/slides/slide21.xml><?xml version="1.0" encoding="utf-8"?>
-<p:sld xmlns:a="http://schemas.openxmlformats.org/drawingml/2006/main" xmlns:r="http://schemas.openxmlformats.org/officeDocument/2006/relationships" xmlns:p="http://schemas.openxmlformats.org/presentationml/2006/main">
-  <p:cSld>
-    <p:spTree>
-      <p:nvGrpSpPr>
-        <p:cNvPr id="1" name=""/>
-        <p:cNvGrpSpPr/>
-        <p:nvPr/>
-      </p:nvGrpSpPr>
-      <p:grpSpPr>
-        <a:xfrm>
-          <a:off x="0" y="0"/>
-          <a:ext cx="0" cy="0"/>
-          <a:chOff x="0" y="0"/>
-          <a:chExt cx="0" cy="0"/>
-        </a:xfrm>
-      </p:grpSpPr>
-      <p:sp>
-        <p:nvSpPr>
           <p:cNvPr id="7170" name="Rectangle 2"/>
           <p:cNvSpPr>
             <a:spLocks noGrp="1" noChangeArrowheads="1"/>
@@ -10594,7 +10493,7 @@
 </p:sld>
 </file>
 
-<file path=ppt/slides/slide22.xml><?xml version="1.0" encoding="utf-8"?>
+<file path=ppt/slides/slide21.xml><?xml version="1.0" encoding="utf-8"?>
 <p:sld xmlns:a="http://schemas.openxmlformats.org/drawingml/2006/main" xmlns:r="http://schemas.openxmlformats.org/officeDocument/2006/relationships" xmlns:p="http://schemas.openxmlformats.org/presentationml/2006/main">
   <p:cSld>
     <p:spTree>
@@ -11001,7 +10900,7 @@
 </p:sld>
 </file>
 
-<file path=ppt/slides/slide23.xml><?xml version="1.0" encoding="utf-8"?>
+<file path=ppt/slides/slide22.xml><?xml version="1.0" encoding="utf-8"?>
 <p:sld xmlns:a="http://schemas.openxmlformats.org/drawingml/2006/main" xmlns:r="http://schemas.openxmlformats.org/officeDocument/2006/relationships" xmlns:p="http://schemas.openxmlformats.org/presentationml/2006/main">
   <p:cSld>
     <p:spTree>
@@ -11391,7 +11290,7 @@
 </p:sld>
 </file>
 
-<file path=ppt/slides/slide24.xml><?xml version="1.0" encoding="utf-8"?>
+<file path=ppt/slides/slide23.xml><?xml version="1.0" encoding="utf-8"?>
 <p:sld xmlns:a="http://schemas.openxmlformats.org/drawingml/2006/main" xmlns:r="http://schemas.openxmlformats.org/officeDocument/2006/relationships" xmlns:p="http://schemas.openxmlformats.org/presentationml/2006/main">
   <p:cSld>
     <p:spTree>
@@ -11562,7 +11461,7 @@
 </p:sld>
 </file>
 
-<file path=ppt/slides/slide25.xml><?xml version="1.0" encoding="utf-8"?>
+<file path=ppt/slides/slide24.xml><?xml version="1.0" encoding="utf-8"?>
 <p:sld xmlns:a="http://schemas.openxmlformats.org/drawingml/2006/main" xmlns:r="http://schemas.openxmlformats.org/officeDocument/2006/relationships" xmlns:p="http://schemas.openxmlformats.org/presentationml/2006/main">
   <p:cSld>
     <p:spTree>
@@ -11965,13 +11864,13 @@
                 </a:solidFill>
                 <a:latin typeface="Arial" panose="020B0604020202020204" pitchFamily="34" charset="0"/>
               </a:rPr>
-              <a:t>data and behavior (</a:t>
+              <a:t>data and behavior </a:t>
             </a:r>
             <a:r>
               <a:rPr lang="en-US" altLang="en-US" sz="2800" dirty="0">
                 <a:latin typeface="Arial" panose="020B0604020202020204" pitchFamily="34" charset="0"/>
               </a:rPr>
-              <a:t>actions called</a:t>
+              <a:t>(actions called</a:t>
             </a:r>
             <a:r>
               <a:rPr lang="en-US" altLang="en-US" sz="2800" b="1" dirty="0">
@@ -11980,7 +11879,13 @@
                 </a:solidFill>
                 <a:latin typeface="Arial" panose="020B0604020202020204" pitchFamily="34" charset="0"/>
               </a:rPr>
-              <a:t> methods).</a:t>
+              <a:t> methods</a:t>
+            </a:r>
+            <a:r>
+              <a:rPr lang="en-US" altLang="en-US" sz="2800" b="1" dirty="0">
+                <a:latin typeface="Arial" panose="020B0604020202020204" pitchFamily="34" charset="0"/>
+              </a:rPr>
+              <a:t>).</a:t>
             </a:r>
           </a:p>
           <a:p>
@@ -12048,25 +11953,7 @@
                 </a:solidFill>
                 <a:latin typeface="Arial" panose="020B0604020202020204" pitchFamily="34" charset="0"/>
               </a:rPr>
-              <a:t>(</a:t>
-            </a:r>
-            <a:r>
-              <a:rPr lang="en-US" altLang="en-US" sz="2800" dirty="0" err="1">
-                <a:solidFill>
-                  <a:srgbClr val="333333"/>
-                </a:solidFill>
-                <a:latin typeface="Arial" panose="020B0604020202020204" pitchFamily="34" charset="0"/>
-              </a:rPr>
-              <a:t>eg</a:t>
-            </a:r>
-            <a:r>
-              <a:rPr lang="en-US" altLang="en-US" sz="2800" dirty="0">
-                <a:solidFill>
-                  <a:srgbClr val="333333"/>
-                </a:solidFill>
-                <a:latin typeface="Arial" panose="020B0604020202020204" pitchFamily="34" charset="0"/>
-              </a:rPr>
-              <a:t>: </a:t>
+              <a:t>(e.g.: </a:t>
             </a:r>
             <a:r>
               <a:rPr lang="en-US" altLang="en-US" sz="2800" dirty="0">
@@ -12152,25 +12039,7 @@
                 </a:solidFill>
                 <a:latin typeface="Arial" panose="020B0604020202020204" pitchFamily="34" charset="0"/>
               </a:rPr>
-              <a:t>(</a:t>
-            </a:r>
-            <a:r>
-              <a:rPr lang="en-US" altLang="en-US" sz="2800" dirty="0" err="1">
-                <a:solidFill>
-                  <a:srgbClr val="333333"/>
-                </a:solidFill>
-                <a:latin typeface="Arial" panose="020B0604020202020204" pitchFamily="34" charset="0"/>
-              </a:rPr>
-              <a:t>eg</a:t>
-            </a:r>
-            <a:r>
-              <a:rPr lang="en-US" altLang="en-US" sz="2800" dirty="0">
-                <a:solidFill>
-                  <a:srgbClr val="333333"/>
-                </a:solidFill>
-                <a:latin typeface="Arial" panose="020B0604020202020204" pitchFamily="34" charset="0"/>
-              </a:rPr>
-              <a:t>: </a:t>
+              <a:t>(e.g.: </a:t>
             </a:r>
             <a:r>
               <a:rPr lang="en-US" altLang="en-US" sz="2800" dirty="0">
@@ -12629,7 +12498,7 @@
 </p:sld>
 </file>
 
-<file path=ppt/slides/slide26.xml><?xml version="1.0" encoding="utf-8"?>
+<file path=ppt/slides/slide25.xml><?xml version="1.0" encoding="utf-8"?>
 <p:sld xmlns:a="http://schemas.openxmlformats.org/drawingml/2006/main" xmlns:r="http://schemas.openxmlformats.org/officeDocument/2006/relationships" xmlns:p="http://schemas.openxmlformats.org/presentationml/2006/main">
   <p:cSld>
     <p:spTree>
@@ -13875,7 +13744,7 @@
 </p:sld>
 </file>
 
-<file path=ppt/slides/slide27.xml><?xml version="1.0" encoding="utf-8"?>
+<file path=ppt/slides/slide26.xml><?xml version="1.0" encoding="utf-8"?>
 <p:sld xmlns:a="http://schemas.openxmlformats.org/drawingml/2006/main" xmlns:r="http://schemas.openxmlformats.org/officeDocument/2006/relationships" xmlns:p="http://schemas.openxmlformats.org/presentationml/2006/main">
   <p:cSld>
     <p:spTree>
@@ -14295,7 +14164,7 @@
 </p:sld>
 </file>
 
-<file path=ppt/slides/slide28.xml><?xml version="1.0" encoding="utf-8"?>
+<file path=ppt/slides/slide27.xml><?xml version="1.0" encoding="utf-8"?>
 <p:sld xmlns:a="http://schemas.openxmlformats.org/drawingml/2006/main" xmlns:r="http://schemas.openxmlformats.org/officeDocument/2006/relationships" xmlns:p="http://schemas.openxmlformats.org/presentationml/2006/main">
   <p:cSld>
     <p:spTree>
@@ -14758,7 +14627,7 @@
 </p:sld>
 </file>
 
-<file path=ppt/slides/slide29.xml><?xml version="1.0" encoding="utf-8"?>
+<file path=ppt/slides/slide28.xml><?xml version="1.0" encoding="utf-8"?>
 <p:sld xmlns:a="http://schemas.openxmlformats.org/drawingml/2006/main" xmlns:r="http://schemas.openxmlformats.org/officeDocument/2006/relationships" xmlns:p="http://schemas.openxmlformats.org/presentationml/2006/main">
   <p:cSld>
     <p:spTree>
@@ -14819,7 +14688,7 @@
         </p:nvSpPr>
         <p:spPr>
           <a:xfrm>
-            <a:off x="1978502" y="2144424"/>
+            <a:off x="1061405" y="1667594"/>
             <a:ext cx="4120195" cy="427529"/>
           </a:xfrm>
           <a:ln>
@@ -14860,7 +14729,7 @@
         </p:nvSpPr>
         <p:spPr bwMode="auto">
           <a:xfrm>
-            <a:off x="3886200" y="2933358"/>
+            <a:off x="3877574" y="2217382"/>
             <a:ext cx="3124200" cy="3657600"/>
           </a:xfrm>
           <a:prstGeom prst="rect">
@@ -15038,7 +14907,7 @@
         </p:nvSpPr>
         <p:spPr bwMode="auto">
           <a:xfrm>
-            <a:off x="5486400" y="2933358"/>
+            <a:off x="5477774" y="2217382"/>
             <a:ext cx="0" cy="3657600"/>
           </a:xfrm>
           <a:prstGeom prst="line">
@@ -15079,7 +14948,7 @@
         </p:nvSpPr>
         <p:spPr bwMode="auto">
           <a:xfrm>
-            <a:off x="4191000" y="3771558"/>
+            <a:off x="4182374" y="3055582"/>
             <a:ext cx="990600" cy="533400"/>
           </a:xfrm>
           <a:prstGeom prst="ellipse">
@@ -15257,7 +15126,7 @@
         </p:nvSpPr>
         <p:spPr bwMode="auto">
           <a:xfrm>
-            <a:off x="6324600" y="3466758"/>
+            <a:off x="6315974" y="2750782"/>
             <a:ext cx="1371600" cy="533400"/>
           </a:xfrm>
           <a:prstGeom prst="rect">
@@ -15435,7 +15304,7 @@
         </p:nvSpPr>
         <p:spPr bwMode="auto">
           <a:xfrm>
-            <a:off x="6324600" y="4381158"/>
+            <a:off x="6315974" y="3665182"/>
             <a:ext cx="1371600" cy="457200"/>
           </a:xfrm>
           <a:prstGeom prst="rect">
@@ -15613,7 +15482,7 @@
         </p:nvSpPr>
         <p:spPr bwMode="auto">
           <a:xfrm>
-            <a:off x="4267200" y="2933358"/>
+            <a:off x="4258574" y="2217382"/>
             <a:ext cx="850900" cy="336550"/>
           </a:xfrm>
           <a:prstGeom prst="rect">
@@ -15805,7 +15674,7 @@
         </p:nvSpPr>
         <p:spPr bwMode="auto">
           <a:xfrm>
-            <a:off x="5791200" y="2933358"/>
+            <a:off x="5782574" y="2217382"/>
             <a:ext cx="782638" cy="336550"/>
           </a:xfrm>
           <a:prstGeom prst="rect">
@@ -15997,7 +15866,7 @@
         </p:nvSpPr>
         <p:spPr bwMode="auto">
           <a:xfrm>
-            <a:off x="4038600" y="5676558"/>
+            <a:off x="4029974" y="4960582"/>
             <a:ext cx="1371600" cy="457200"/>
           </a:xfrm>
           <a:prstGeom prst="rect">
@@ -16175,7 +16044,7 @@
         </p:nvSpPr>
         <p:spPr bwMode="auto">
           <a:xfrm>
-            <a:off x="4191000" y="4609758"/>
+            <a:off x="4182374" y="3893782"/>
             <a:ext cx="990600" cy="533400"/>
           </a:xfrm>
           <a:prstGeom prst="ellipse">
@@ -16353,7 +16222,7 @@
         </p:nvSpPr>
         <p:spPr bwMode="auto">
           <a:xfrm>
-            <a:off x="6324600" y="5295558"/>
+            <a:off x="6315974" y="4579582"/>
             <a:ext cx="1371600" cy="533400"/>
           </a:xfrm>
           <a:prstGeom prst="rect">
@@ -16531,7 +16400,7 @@
         </p:nvSpPr>
         <p:spPr bwMode="auto">
           <a:xfrm>
-            <a:off x="9220200" y="2857158"/>
+            <a:off x="9211574" y="2141182"/>
             <a:ext cx="1066800" cy="533400"/>
           </a:xfrm>
           <a:prstGeom prst="rect">
@@ -16709,7 +16578,7 @@
         </p:nvSpPr>
         <p:spPr bwMode="auto">
           <a:xfrm flipH="1">
-            <a:off x="7696200" y="3390558"/>
+            <a:off x="7687574" y="2674582"/>
             <a:ext cx="1752600" cy="381000"/>
           </a:xfrm>
           <a:prstGeom prst="line">
@@ -16751,7 +16620,7 @@
         </p:nvSpPr>
         <p:spPr bwMode="auto">
           <a:xfrm flipH="1">
-            <a:off x="7696200" y="3390558"/>
+            <a:off x="7687574" y="2674582"/>
             <a:ext cx="1981200" cy="1219200"/>
           </a:xfrm>
           <a:prstGeom prst="line">
@@ -16793,7 +16662,7 @@
         </p:nvSpPr>
         <p:spPr bwMode="auto">
           <a:xfrm flipH="1">
-            <a:off x="7696200" y="3390558"/>
+            <a:off x="7687574" y="2674582"/>
             <a:ext cx="2438400" cy="2209800"/>
           </a:xfrm>
           <a:prstGeom prst="line">
@@ -16835,7 +16704,7 @@
         </p:nvSpPr>
         <p:spPr bwMode="auto">
           <a:xfrm>
-            <a:off x="7924800" y="4000158"/>
+            <a:off x="7916174" y="3284182"/>
             <a:ext cx="2362200" cy="523220"/>
           </a:xfrm>
           <a:prstGeom prst="rect">
@@ -17030,7 +16899,7 @@
         </p:nvSpPr>
         <p:spPr bwMode="auto">
           <a:xfrm flipH="1">
-            <a:off x="3429000" y="4076358"/>
+            <a:off x="3420374" y="3360382"/>
             <a:ext cx="762000" cy="533400"/>
           </a:xfrm>
           <a:prstGeom prst="line">
@@ -17071,7 +16940,7 @@
         </p:nvSpPr>
         <p:spPr bwMode="auto">
           <a:xfrm flipH="1" flipV="1">
-            <a:off x="3429000" y="4609758"/>
+            <a:off x="3420374" y="3893782"/>
             <a:ext cx="762000" cy="304800"/>
           </a:xfrm>
           <a:prstGeom prst="line">
@@ -17112,7 +16981,7 @@
         </p:nvSpPr>
         <p:spPr bwMode="auto">
           <a:xfrm>
-            <a:off x="2895601" y="4381158"/>
+            <a:off x="2886975" y="3665182"/>
             <a:ext cx="601663" cy="336550"/>
           </a:xfrm>
           <a:prstGeom prst="rect">
@@ -17304,7 +17173,7 @@
         </p:nvSpPr>
         <p:spPr bwMode="auto">
           <a:xfrm>
-            <a:off x="6934200" y="5828958"/>
+            <a:off x="6925574" y="5112982"/>
             <a:ext cx="1295400" cy="609600"/>
           </a:xfrm>
           <a:prstGeom prst="line">
@@ -17345,7 +17214,7 @@
         </p:nvSpPr>
         <p:spPr bwMode="auto">
           <a:xfrm>
-            <a:off x="5334000" y="6209958"/>
+            <a:off x="5325374" y="5493982"/>
             <a:ext cx="2895600" cy="228600"/>
           </a:xfrm>
           <a:prstGeom prst="line">
@@ -17386,7 +17255,7 @@
         </p:nvSpPr>
         <p:spPr bwMode="auto">
           <a:xfrm>
-            <a:off x="8229600" y="6286158"/>
+            <a:off x="8220974" y="5570182"/>
             <a:ext cx="922338" cy="304800"/>
           </a:xfrm>
           <a:prstGeom prst="rect">
@@ -17752,10 +17621,293 @@
           </a:p>
         </p:txBody>
       </p:sp>
+      <p:sp>
+        <p:nvSpPr>
+          <p:cNvPr id="3" name="TextBox 2">
+            <a:extLst>
+              <a:ext uri="{FF2B5EF4-FFF2-40B4-BE49-F238E27FC236}">
+                <a16:creationId xmlns:a16="http://schemas.microsoft.com/office/drawing/2014/main" id="{EAFA684C-4169-0629-189D-6E06FB37A574}"/>
+              </a:ext>
+            </a:extLst>
+          </p:cNvPr>
+          <p:cNvSpPr txBox="1"/>
+          <p:nvPr/>
+        </p:nvSpPr>
+        <p:spPr>
+          <a:xfrm>
+            <a:off x="3626971" y="5934720"/>
+            <a:ext cx="3954929" cy="646331"/>
+          </a:xfrm>
+          <a:prstGeom prst="rect">
+            <a:avLst/>
+          </a:prstGeom>
+          <a:noFill/>
+        </p:spPr>
+        <p:txBody>
+          <a:bodyPr wrap="none" rtlCol="0">
+            <a:spAutoFit/>
+          </a:bodyPr>
+          <a:lstStyle/>
+          <a:p>
+            <a:r>
+              <a:rPr lang="en-US" dirty="0"/>
+              <a:t>(pre-standard OO modeling notation)</a:t>
+            </a:r>
+          </a:p>
+          <a:p>
+            <a:pPr algn="ctr"/>
+            <a:r>
+              <a:rPr lang="en-US" dirty="0"/>
+              <a:t>Class Diagram</a:t>
+            </a:r>
+          </a:p>
+        </p:txBody>
+      </p:sp>
     </p:spTree>
     <p:extLst>
       <p:ext uri="{BB962C8B-B14F-4D97-AF65-F5344CB8AC3E}">
         <p14:creationId xmlns:p14="http://schemas.microsoft.com/office/powerpoint/2010/main" val="4147680008"/>
+      </p:ext>
+    </p:extLst>
+  </p:cSld>
+  <p:clrMapOvr>
+    <a:masterClrMapping/>
+  </p:clrMapOvr>
+</p:sld>
+</file>
+
+<file path=ppt/slides/slide29.xml><?xml version="1.0" encoding="utf-8"?>
+<p:sld xmlns:a="http://schemas.openxmlformats.org/drawingml/2006/main" xmlns:r="http://schemas.openxmlformats.org/officeDocument/2006/relationships" xmlns:p="http://schemas.openxmlformats.org/presentationml/2006/main">
+  <p:cSld>
+    <p:spTree>
+      <p:nvGrpSpPr>
+        <p:cNvPr id="1" name=""/>
+        <p:cNvGrpSpPr/>
+        <p:nvPr/>
+      </p:nvGrpSpPr>
+      <p:grpSpPr>
+        <a:xfrm>
+          <a:off x="0" y="0"/>
+          <a:ext cx="0" cy="0"/>
+          <a:chOff x="0" y="0"/>
+          <a:chExt cx="0" cy="0"/>
+        </a:xfrm>
+      </p:grpSpPr>
+      <p:sp>
+        <p:nvSpPr>
+          <p:cNvPr id="2" name="Title 1"/>
+          <p:cNvSpPr>
+            <a:spLocks noGrp="1"/>
+          </p:cNvSpPr>
+          <p:nvPr>
+            <p:ph type="ctrTitle"/>
+          </p:nvPr>
+        </p:nvSpPr>
+        <p:spPr/>
+        <p:txBody>
+          <a:bodyPr rtlCol="0">
+            <a:normAutofit/>
+          </a:bodyPr>
+          <a:lstStyle/>
+          <a:p>
+            <a:pPr>
+              <a:defRPr/>
+            </a:pPr>
+            <a:r>
+              <a:rPr lang="en-US" dirty="0"/>
+              <a:t>Class and inheritance</a:t>
+            </a:r>
+          </a:p>
+        </p:txBody>
+      </p:sp>
+      <p:sp>
+        <p:nvSpPr>
+          <p:cNvPr id="5123" name="Slide Number Placeholder 3"/>
+          <p:cNvSpPr>
+            <a:spLocks noGrp="1"/>
+          </p:cNvSpPr>
+          <p:nvPr>
+            <p:ph type="sldNum" sz="quarter" idx="4294967295"/>
+          </p:nvPr>
+        </p:nvSpPr>
+        <p:spPr bwMode="auto">
+          <a:noFill/>
+          <a:extLst>
+            <a:ext uri="{909E8E84-426E-40DD-AFC4-6F175D3DCCD1}">
+              <a14:hiddenFill xmlns:a14="http://schemas.microsoft.com/office/drawing/2010/main">
+                <a:solidFill>
+                  <a:srgbClr val="FFFFFF"/>
+                </a:solidFill>
+              </a14:hiddenFill>
+            </a:ext>
+            <a:ext uri="{91240B29-F687-4F45-9708-019B960494DF}">
+              <a14:hiddenLine xmlns:a14="http://schemas.microsoft.com/office/drawing/2010/main" w="9525">
+                <a:solidFill>
+                  <a:srgbClr val="000000"/>
+                </a:solidFill>
+                <a:miter lim="800000"/>
+                <a:headEnd/>
+                <a:tailEnd/>
+              </a14:hiddenLine>
+            </a:ext>
+          </a:extLst>
+        </p:spPr>
+        <p:txBody>
+          <a:bodyPr/>
+          <a:lstStyle>
+            <a:lvl1pPr>
+              <a:spcBef>
+                <a:spcPct val="20000"/>
+              </a:spcBef>
+              <a:buFont typeface="Arial" panose="020B0604020202020204" pitchFamily="34" charset="0"/>
+              <a:buChar char="•"/>
+              <a:defRPr sz="3200">
+                <a:solidFill>
+                  <a:schemeClr val="tx1"/>
+                </a:solidFill>
+                <a:latin typeface="Calibri" panose="020F0502020204030204" pitchFamily="34" charset="0"/>
+              </a:defRPr>
+            </a:lvl1pPr>
+            <a:lvl2pPr marL="742950" indent="-285750">
+              <a:spcBef>
+                <a:spcPct val="20000"/>
+              </a:spcBef>
+              <a:buFont typeface="Arial" panose="020B0604020202020204" pitchFamily="34" charset="0"/>
+              <a:buChar char="–"/>
+              <a:defRPr sz="2800">
+                <a:solidFill>
+                  <a:schemeClr val="tx1"/>
+                </a:solidFill>
+                <a:latin typeface="Calibri" panose="020F0502020204030204" pitchFamily="34" charset="0"/>
+              </a:defRPr>
+            </a:lvl2pPr>
+            <a:lvl3pPr marL="1143000" indent="-228600">
+              <a:spcBef>
+                <a:spcPct val="20000"/>
+              </a:spcBef>
+              <a:buFont typeface="Arial" panose="020B0604020202020204" pitchFamily="34" charset="0"/>
+              <a:buChar char="•"/>
+              <a:defRPr sz="2400">
+                <a:solidFill>
+                  <a:schemeClr val="tx1"/>
+                </a:solidFill>
+                <a:latin typeface="Calibri" panose="020F0502020204030204" pitchFamily="34" charset="0"/>
+              </a:defRPr>
+            </a:lvl3pPr>
+            <a:lvl4pPr marL="1600200" indent="-228600">
+              <a:spcBef>
+                <a:spcPct val="20000"/>
+              </a:spcBef>
+              <a:buFont typeface="Arial" panose="020B0604020202020204" pitchFamily="34" charset="0"/>
+              <a:buChar char="–"/>
+              <a:defRPr sz="2000">
+                <a:solidFill>
+                  <a:schemeClr val="tx1"/>
+                </a:solidFill>
+                <a:latin typeface="Calibri" panose="020F0502020204030204" pitchFamily="34" charset="0"/>
+              </a:defRPr>
+            </a:lvl4pPr>
+            <a:lvl5pPr marL="2057400" indent="-228600">
+              <a:spcBef>
+                <a:spcPct val="20000"/>
+              </a:spcBef>
+              <a:buFont typeface="Arial" panose="020B0604020202020204" pitchFamily="34" charset="0"/>
+              <a:buChar char="»"/>
+              <a:defRPr sz="2000">
+                <a:solidFill>
+                  <a:schemeClr val="tx1"/>
+                </a:solidFill>
+                <a:latin typeface="Calibri" panose="020F0502020204030204" pitchFamily="34" charset="0"/>
+              </a:defRPr>
+            </a:lvl5pPr>
+            <a:lvl6pPr marL="2514600" indent="-228600" eaLnBrk="0" fontAlgn="base" hangingPunct="0">
+              <a:spcBef>
+                <a:spcPct val="20000"/>
+              </a:spcBef>
+              <a:spcAft>
+                <a:spcPct val="0"/>
+              </a:spcAft>
+              <a:buFont typeface="Arial" panose="020B0604020202020204" pitchFamily="34" charset="0"/>
+              <a:buChar char="»"/>
+              <a:defRPr sz="2000">
+                <a:solidFill>
+                  <a:schemeClr val="tx1"/>
+                </a:solidFill>
+                <a:latin typeface="Calibri" panose="020F0502020204030204" pitchFamily="34" charset="0"/>
+              </a:defRPr>
+            </a:lvl6pPr>
+            <a:lvl7pPr marL="2971800" indent="-228600" eaLnBrk="0" fontAlgn="base" hangingPunct="0">
+              <a:spcBef>
+                <a:spcPct val="20000"/>
+              </a:spcBef>
+              <a:spcAft>
+                <a:spcPct val="0"/>
+              </a:spcAft>
+              <a:buFont typeface="Arial" panose="020B0604020202020204" pitchFamily="34" charset="0"/>
+              <a:buChar char="»"/>
+              <a:defRPr sz="2000">
+                <a:solidFill>
+                  <a:schemeClr val="tx1"/>
+                </a:solidFill>
+                <a:latin typeface="Calibri" panose="020F0502020204030204" pitchFamily="34" charset="0"/>
+              </a:defRPr>
+            </a:lvl7pPr>
+            <a:lvl8pPr marL="3429000" indent="-228600" eaLnBrk="0" fontAlgn="base" hangingPunct="0">
+              <a:spcBef>
+                <a:spcPct val="20000"/>
+              </a:spcBef>
+              <a:spcAft>
+                <a:spcPct val="0"/>
+              </a:spcAft>
+              <a:buFont typeface="Arial" panose="020B0604020202020204" pitchFamily="34" charset="0"/>
+              <a:buChar char="»"/>
+              <a:defRPr sz="2000">
+                <a:solidFill>
+                  <a:schemeClr val="tx1"/>
+                </a:solidFill>
+                <a:latin typeface="Calibri" panose="020F0502020204030204" pitchFamily="34" charset="0"/>
+              </a:defRPr>
+            </a:lvl8pPr>
+            <a:lvl9pPr marL="3886200" indent="-228600" eaLnBrk="0" fontAlgn="base" hangingPunct="0">
+              <a:spcBef>
+                <a:spcPct val="20000"/>
+              </a:spcBef>
+              <a:spcAft>
+                <a:spcPct val="0"/>
+              </a:spcAft>
+              <a:buFont typeface="Arial" panose="020B0604020202020204" pitchFamily="34" charset="0"/>
+              <a:buChar char="»"/>
+              <a:defRPr sz="2000">
+                <a:solidFill>
+                  <a:schemeClr val="tx1"/>
+                </a:solidFill>
+                <a:latin typeface="Calibri" panose="020F0502020204030204" pitchFamily="34" charset="0"/>
+              </a:defRPr>
+            </a:lvl9pPr>
+          </a:lstStyle>
+          <a:p>
+            <a:pPr>
+              <a:spcBef>
+                <a:spcPct val="0"/>
+              </a:spcBef>
+              <a:buFontTx/>
+              <a:buNone/>
+            </a:pPr>
+            <a:r>
+              <a:rPr lang="en-US" altLang="en-US" sz="1200" dirty="0">
+                <a:solidFill>
+                  <a:srgbClr val="898989"/>
+                </a:solidFill>
+              </a:rPr>
+              <a:t> </a:t>
+            </a:r>
+          </a:p>
+        </p:txBody>
+      </p:sp>
+    </p:spTree>
+    <p:extLst>
+      <p:ext uri="{BB962C8B-B14F-4D97-AF65-F5344CB8AC3E}">
+        <p14:creationId xmlns:p14="http://schemas.microsoft.com/office/powerpoint/2010/main" val="2527448594"/>
       </p:ext>
     </p:extLst>
   </p:cSld>
@@ -18010,247 +18162,6 @@
       </p:grpSpPr>
       <p:sp>
         <p:nvSpPr>
-          <p:cNvPr id="2" name="Title 1"/>
-          <p:cNvSpPr>
-            <a:spLocks noGrp="1"/>
-          </p:cNvSpPr>
-          <p:nvPr>
-            <p:ph type="ctrTitle"/>
-          </p:nvPr>
-        </p:nvSpPr>
-        <p:spPr/>
-        <p:txBody>
-          <a:bodyPr rtlCol="0">
-            <a:normAutofit/>
-          </a:bodyPr>
-          <a:lstStyle/>
-          <a:p>
-            <a:pPr>
-              <a:defRPr/>
-            </a:pPr>
-            <a:r>
-              <a:rPr lang="en-US" dirty="0"/>
-              <a:t>Class and inheritance</a:t>
-            </a:r>
-          </a:p>
-        </p:txBody>
-      </p:sp>
-      <p:sp>
-        <p:nvSpPr>
-          <p:cNvPr id="5123" name="Slide Number Placeholder 3"/>
-          <p:cNvSpPr>
-            <a:spLocks noGrp="1"/>
-          </p:cNvSpPr>
-          <p:nvPr>
-            <p:ph type="sldNum" sz="quarter" idx="4294967295"/>
-          </p:nvPr>
-        </p:nvSpPr>
-        <p:spPr bwMode="auto">
-          <a:noFill/>
-          <a:extLst>
-            <a:ext uri="{909E8E84-426E-40DD-AFC4-6F175D3DCCD1}">
-              <a14:hiddenFill xmlns:a14="http://schemas.microsoft.com/office/drawing/2010/main">
-                <a:solidFill>
-                  <a:srgbClr val="FFFFFF"/>
-                </a:solidFill>
-              </a14:hiddenFill>
-            </a:ext>
-            <a:ext uri="{91240B29-F687-4F45-9708-019B960494DF}">
-              <a14:hiddenLine xmlns:a14="http://schemas.microsoft.com/office/drawing/2010/main" w="9525">
-                <a:solidFill>
-                  <a:srgbClr val="000000"/>
-                </a:solidFill>
-                <a:miter lim="800000"/>
-                <a:headEnd/>
-                <a:tailEnd/>
-              </a14:hiddenLine>
-            </a:ext>
-          </a:extLst>
-        </p:spPr>
-        <p:txBody>
-          <a:bodyPr/>
-          <a:lstStyle>
-            <a:lvl1pPr>
-              <a:spcBef>
-                <a:spcPct val="20000"/>
-              </a:spcBef>
-              <a:buFont typeface="Arial" panose="020B0604020202020204" pitchFamily="34" charset="0"/>
-              <a:buChar char="•"/>
-              <a:defRPr sz="3200">
-                <a:solidFill>
-                  <a:schemeClr val="tx1"/>
-                </a:solidFill>
-                <a:latin typeface="Calibri" panose="020F0502020204030204" pitchFamily="34" charset="0"/>
-              </a:defRPr>
-            </a:lvl1pPr>
-            <a:lvl2pPr marL="742950" indent="-285750">
-              <a:spcBef>
-                <a:spcPct val="20000"/>
-              </a:spcBef>
-              <a:buFont typeface="Arial" panose="020B0604020202020204" pitchFamily="34" charset="0"/>
-              <a:buChar char="–"/>
-              <a:defRPr sz="2800">
-                <a:solidFill>
-                  <a:schemeClr val="tx1"/>
-                </a:solidFill>
-                <a:latin typeface="Calibri" panose="020F0502020204030204" pitchFamily="34" charset="0"/>
-              </a:defRPr>
-            </a:lvl2pPr>
-            <a:lvl3pPr marL="1143000" indent="-228600">
-              <a:spcBef>
-                <a:spcPct val="20000"/>
-              </a:spcBef>
-              <a:buFont typeface="Arial" panose="020B0604020202020204" pitchFamily="34" charset="0"/>
-              <a:buChar char="•"/>
-              <a:defRPr sz="2400">
-                <a:solidFill>
-                  <a:schemeClr val="tx1"/>
-                </a:solidFill>
-                <a:latin typeface="Calibri" panose="020F0502020204030204" pitchFamily="34" charset="0"/>
-              </a:defRPr>
-            </a:lvl3pPr>
-            <a:lvl4pPr marL="1600200" indent="-228600">
-              <a:spcBef>
-                <a:spcPct val="20000"/>
-              </a:spcBef>
-              <a:buFont typeface="Arial" panose="020B0604020202020204" pitchFamily="34" charset="0"/>
-              <a:buChar char="–"/>
-              <a:defRPr sz="2000">
-                <a:solidFill>
-                  <a:schemeClr val="tx1"/>
-                </a:solidFill>
-                <a:latin typeface="Calibri" panose="020F0502020204030204" pitchFamily="34" charset="0"/>
-              </a:defRPr>
-            </a:lvl4pPr>
-            <a:lvl5pPr marL="2057400" indent="-228600">
-              <a:spcBef>
-                <a:spcPct val="20000"/>
-              </a:spcBef>
-              <a:buFont typeface="Arial" panose="020B0604020202020204" pitchFamily="34" charset="0"/>
-              <a:buChar char="»"/>
-              <a:defRPr sz="2000">
-                <a:solidFill>
-                  <a:schemeClr val="tx1"/>
-                </a:solidFill>
-                <a:latin typeface="Calibri" panose="020F0502020204030204" pitchFamily="34" charset="0"/>
-              </a:defRPr>
-            </a:lvl5pPr>
-            <a:lvl6pPr marL="2514600" indent="-228600" eaLnBrk="0" fontAlgn="base" hangingPunct="0">
-              <a:spcBef>
-                <a:spcPct val="20000"/>
-              </a:spcBef>
-              <a:spcAft>
-                <a:spcPct val="0"/>
-              </a:spcAft>
-              <a:buFont typeface="Arial" panose="020B0604020202020204" pitchFamily="34" charset="0"/>
-              <a:buChar char="»"/>
-              <a:defRPr sz="2000">
-                <a:solidFill>
-                  <a:schemeClr val="tx1"/>
-                </a:solidFill>
-                <a:latin typeface="Calibri" panose="020F0502020204030204" pitchFamily="34" charset="0"/>
-              </a:defRPr>
-            </a:lvl6pPr>
-            <a:lvl7pPr marL="2971800" indent="-228600" eaLnBrk="0" fontAlgn="base" hangingPunct="0">
-              <a:spcBef>
-                <a:spcPct val="20000"/>
-              </a:spcBef>
-              <a:spcAft>
-                <a:spcPct val="0"/>
-              </a:spcAft>
-              <a:buFont typeface="Arial" panose="020B0604020202020204" pitchFamily="34" charset="0"/>
-              <a:buChar char="»"/>
-              <a:defRPr sz="2000">
-                <a:solidFill>
-                  <a:schemeClr val="tx1"/>
-                </a:solidFill>
-                <a:latin typeface="Calibri" panose="020F0502020204030204" pitchFamily="34" charset="0"/>
-              </a:defRPr>
-            </a:lvl7pPr>
-            <a:lvl8pPr marL="3429000" indent="-228600" eaLnBrk="0" fontAlgn="base" hangingPunct="0">
-              <a:spcBef>
-                <a:spcPct val="20000"/>
-              </a:spcBef>
-              <a:spcAft>
-                <a:spcPct val="0"/>
-              </a:spcAft>
-              <a:buFont typeface="Arial" panose="020B0604020202020204" pitchFamily="34" charset="0"/>
-              <a:buChar char="»"/>
-              <a:defRPr sz="2000">
-                <a:solidFill>
-                  <a:schemeClr val="tx1"/>
-                </a:solidFill>
-                <a:latin typeface="Calibri" panose="020F0502020204030204" pitchFamily="34" charset="0"/>
-              </a:defRPr>
-            </a:lvl8pPr>
-            <a:lvl9pPr marL="3886200" indent="-228600" eaLnBrk="0" fontAlgn="base" hangingPunct="0">
-              <a:spcBef>
-                <a:spcPct val="20000"/>
-              </a:spcBef>
-              <a:spcAft>
-                <a:spcPct val="0"/>
-              </a:spcAft>
-              <a:buFont typeface="Arial" panose="020B0604020202020204" pitchFamily="34" charset="0"/>
-              <a:buChar char="»"/>
-              <a:defRPr sz="2000">
-                <a:solidFill>
-                  <a:schemeClr val="tx1"/>
-                </a:solidFill>
-                <a:latin typeface="Calibri" panose="020F0502020204030204" pitchFamily="34" charset="0"/>
-              </a:defRPr>
-            </a:lvl9pPr>
-          </a:lstStyle>
-          <a:p>
-            <a:pPr>
-              <a:spcBef>
-                <a:spcPct val="0"/>
-              </a:spcBef>
-              <a:buFontTx/>
-              <a:buNone/>
-            </a:pPr>
-            <a:r>
-              <a:rPr lang="en-US" altLang="en-US" sz="1200" dirty="0">
-                <a:solidFill>
-                  <a:srgbClr val="898989"/>
-                </a:solidFill>
-              </a:rPr>
-              <a:t> </a:t>
-            </a:r>
-          </a:p>
-        </p:txBody>
-      </p:sp>
-    </p:spTree>
-    <p:extLst>
-      <p:ext uri="{BB962C8B-B14F-4D97-AF65-F5344CB8AC3E}">
-        <p14:creationId xmlns:p14="http://schemas.microsoft.com/office/powerpoint/2010/main" val="2527448594"/>
-      </p:ext>
-    </p:extLst>
-  </p:cSld>
-  <p:clrMapOvr>
-    <a:masterClrMapping/>
-  </p:clrMapOvr>
-</p:sld>
-</file>
-
-<file path=ppt/slides/slide31.xml><?xml version="1.0" encoding="utf-8"?>
-<p:sld xmlns:a="http://schemas.openxmlformats.org/drawingml/2006/main" xmlns:r="http://schemas.openxmlformats.org/officeDocument/2006/relationships" xmlns:p="http://schemas.openxmlformats.org/presentationml/2006/main">
-  <p:cSld>
-    <p:spTree>
-      <p:nvGrpSpPr>
-        <p:cNvPr id="1" name=""/>
-        <p:cNvGrpSpPr/>
-        <p:nvPr/>
-      </p:nvGrpSpPr>
-      <p:grpSpPr>
-        <a:xfrm>
-          <a:off x="0" y="0"/>
-          <a:ext cx="0" cy="0"/>
-          <a:chOff x="0" y="0"/>
-          <a:chExt cx="0" cy="0"/>
-        </a:xfrm>
-      </p:grpSpPr>
-      <p:sp>
-        <p:nvSpPr>
           <p:cNvPr id="13314" name="Rectangle 2"/>
           <p:cNvSpPr>
             <a:spLocks noGrp="1" noChangeArrowheads="1"/>
@@ -18593,7 +18504,7 @@
 </p:sld>
 </file>
 
-<file path=ppt/slides/slide32.xml><?xml version="1.0" encoding="utf-8"?>
+<file path=ppt/slides/slide31.xml><?xml version="1.0" encoding="utf-8"?>
 <p:sld xmlns:a="http://schemas.openxmlformats.org/drawingml/2006/main" xmlns:r="http://schemas.openxmlformats.org/officeDocument/2006/relationships" xmlns:p="http://schemas.openxmlformats.org/presentationml/2006/main">
   <p:cSld>
     <p:spTree>
@@ -22064,7 +21975,7 @@
         </p:nvSpPr>
         <p:spPr bwMode="auto">
           <a:xfrm>
-            <a:off x="2209800" y="5943598"/>
+            <a:off x="2171700" y="5676898"/>
             <a:ext cx="3429000" cy="457200"/>
           </a:xfrm>
           <a:prstGeom prst="rect">
@@ -22271,7 +22182,7 @@
         </p:nvSpPr>
         <p:spPr bwMode="auto">
           <a:xfrm>
-            <a:off x="6781800" y="5714998"/>
+            <a:off x="6978941" y="5714998"/>
             <a:ext cx="3429000" cy="869950"/>
           </a:xfrm>
           <a:prstGeom prst="rect">
@@ -22694,6 +22605,193 @@
           </a:p>
         </p:txBody>
       </p:sp>
+      <p:sp>
+        <p:nvSpPr>
+          <p:cNvPr id="2" name="TextBox 1">
+            <a:extLst>
+              <a:ext uri="{FF2B5EF4-FFF2-40B4-BE49-F238E27FC236}">
+                <a16:creationId xmlns:a16="http://schemas.microsoft.com/office/drawing/2014/main" id="{1671EAB2-C891-FB7E-C218-539D2BC28381}"/>
+              </a:ext>
+            </a:extLst>
+          </p:cNvPr>
+          <p:cNvSpPr txBox="1"/>
+          <p:nvPr/>
+        </p:nvSpPr>
+        <p:spPr>
+          <a:xfrm>
+            <a:off x="4897438" y="806113"/>
+            <a:ext cx="3954929" cy="369332"/>
+          </a:xfrm>
+          <a:prstGeom prst="rect">
+            <a:avLst/>
+          </a:prstGeom>
+          <a:noFill/>
+        </p:spPr>
+        <p:txBody>
+          <a:bodyPr wrap="none" rtlCol="0">
+            <a:spAutoFit/>
+          </a:bodyPr>
+          <a:lstStyle/>
+          <a:p>
+            <a:r>
+              <a:rPr lang="en-US" dirty="0"/>
+              <a:t>(pre-standard OO modeling notation)</a:t>
+            </a:r>
+          </a:p>
+        </p:txBody>
+      </p:sp>
+      <p:cxnSp>
+        <p:nvCxnSpPr>
+          <p:cNvPr id="4" name="Straight Arrow Connector 3">
+            <a:extLst>
+              <a:ext uri="{FF2B5EF4-FFF2-40B4-BE49-F238E27FC236}">
+                <a16:creationId xmlns:a16="http://schemas.microsoft.com/office/drawing/2014/main" id="{292094DB-48A9-8ECE-452E-C1BA0B957C0B}"/>
+              </a:ext>
+            </a:extLst>
+          </p:cNvPr>
+          <p:cNvCxnSpPr>
+            <a:stCxn id="2" idx="2"/>
+          </p:cNvCxnSpPr>
+          <p:nvPr/>
+        </p:nvCxnSpPr>
+        <p:spPr>
+          <a:xfrm flipH="1">
+            <a:off x="4114800" y="1175445"/>
+            <a:ext cx="2760103" cy="713740"/>
+          </a:xfrm>
+          <a:prstGeom prst="straightConnector1">
+            <a:avLst/>
+          </a:prstGeom>
+          <a:ln>
+            <a:tailEnd type="triangle"/>
+          </a:ln>
+        </p:spPr>
+        <p:style>
+          <a:lnRef idx="1">
+            <a:schemeClr val="accent1"/>
+          </a:lnRef>
+          <a:fillRef idx="0">
+            <a:schemeClr val="accent1"/>
+          </a:fillRef>
+          <a:effectRef idx="0">
+            <a:schemeClr val="accent1"/>
+          </a:effectRef>
+          <a:fontRef idx="minor">
+            <a:schemeClr val="tx1"/>
+          </a:fontRef>
+        </p:style>
+      </p:cxnSp>
+      <p:cxnSp>
+        <p:nvCxnSpPr>
+          <p:cNvPr id="6" name="Straight Arrow Connector 5">
+            <a:extLst>
+              <a:ext uri="{FF2B5EF4-FFF2-40B4-BE49-F238E27FC236}">
+                <a16:creationId xmlns:a16="http://schemas.microsoft.com/office/drawing/2014/main" id="{88351986-C62A-2264-9AAB-EAD77459FED3}"/>
+              </a:ext>
+            </a:extLst>
+          </p:cNvPr>
+          <p:cNvCxnSpPr>
+            <a:stCxn id="2" idx="2"/>
+          </p:cNvCxnSpPr>
+          <p:nvPr/>
+        </p:nvCxnSpPr>
+        <p:spPr>
+          <a:xfrm>
+            <a:off x="6874903" y="1175445"/>
+            <a:ext cx="1964297" cy="713740"/>
+          </a:xfrm>
+          <a:prstGeom prst="straightConnector1">
+            <a:avLst/>
+          </a:prstGeom>
+          <a:ln>
+            <a:tailEnd type="triangle"/>
+          </a:ln>
+        </p:spPr>
+        <p:style>
+          <a:lnRef idx="1">
+            <a:schemeClr val="accent1"/>
+          </a:lnRef>
+          <a:fillRef idx="0">
+            <a:schemeClr val="accent1"/>
+          </a:fillRef>
+          <a:effectRef idx="0">
+            <a:schemeClr val="accent1"/>
+          </a:effectRef>
+          <a:fontRef idx="minor">
+            <a:schemeClr val="tx1"/>
+          </a:fontRef>
+        </p:style>
+      </p:cxnSp>
+      <p:sp>
+        <p:nvSpPr>
+          <p:cNvPr id="7" name="TextBox 6">
+            <a:extLst>
+              <a:ext uri="{FF2B5EF4-FFF2-40B4-BE49-F238E27FC236}">
+                <a16:creationId xmlns:a16="http://schemas.microsoft.com/office/drawing/2014/main" id="{EA1F64CB-8126-BB02-454A-972650553E01}"/>
+              </a:ext>
+            </a:extLst>
+          </p:cNvPr>
+          <p:cNvSpPr txBox="1"/>
+          <p:nvPr/>
+        </p:nvSpPr>
+        <p:spPr>
+          <a:xfrm>
+            <a:off x="10134600" y="1519853"/>
+            <a:ext cx="1787669" cy="369332"/>
+          </a:xfrm>
+          <a:prstGeom prst="rect">
+            <a:avLst/>
+          </a:prstGeom>
+          <a:noFill/>
+        </p:spPr>
+        <p:txBody>
+          <a:bodyPr wrap="none" rtlCol="0">
+            <a:spAutoFit/>
+          </a:bodyPr>
+          <a:lstStyle/>
+          <a:p>
+            <a:r>
+              <a:rPr lang="en-US" dirty="0"/>
+              <a:t>Object Diagram</a:t>
+            </a:r>
+          </a:p>
+        </p:txBody>
+      </p:sp>
+      <p:sp>
+        <p:nvSpPr>
+          <p:cNvPr id="8" name="TextBox 7">
+            <a:extLst>
+              <a:ext uri="{FF2B5EF4-FFF2-40B4-BE49-F238E27FC236}">
+                <a16:creationId xmlns:a16="http://schemas.microsoft.com/office/drawing/2014/main" id="{79F20703-C33F-E074-5124-1E903224F09E}"/>
+              </a:ext>
+            </a:extLst>
+          </p:cNvPr>
+          <p:cNvSpPr txBox="1"/>
+          <p:nvPr/>
+        </p:nvSpPr>
+        <p:spPr>
+          <a:xfrm>
+            <a:off x="370250" y="1611866"/>
+            <a:ext cx="1697901" cy="369332"/>
+          </a:xfrm>
+          <a:prstGeom prst="rect">
+            <a:avLst/>
+          </a:prstGeom>
+          <a:noFill/>
+        </p:spPr>
+        <p:txBody>
+          <a:bodyPr wrap="none" rtlCol="0">
+            <a:spAutoFit/>
+          </a:bodyPr>
+          <a:lstStyle/>
+          <a:p>
+            <a:r>
+              <a:rPr lang="en-US" dirty="0"/>
+              <a:t>Class Diagram</a:t>
+            </a:r>
+          </a:p>
+        </p:txBody>
+      </p:sp>
     </p:spTree>
     <p:extLst>
       <p:ext uri="{BB962C8B-B14F-4D97-AF65-F5344CB8AC3E}">
@@ -22707,7 +22805,7 @@
 </p:sld>
 </file>
 
-<file path=ppt/slides/slide33.xml><?xml version="1.0" encoding="utf-8"?>
+<file path=ppt/slides/slide32.xml><?xml version="1.0" encoding="utf-8"?>
 <p:sld xmlns:a="http://schemas.openxmlformats.org/drawingml/2006/main" xmlns:r="http://schemas.openxmlformats.org/officeDocument/2006/relationships" xmlns:p="http://schemas.openxmlformats.org/presentationml/2006/main">
   <p:cSld>
     <p:spTree>
@@ -22955,7 +23053,7 @@
 </p:sld>
 </file>
 
-<file path=ppt/slides/slide34.xml><?xml version="1.0" encoding="utf-8"?>
+<file path=ppt/slides/slide33.xml><?xml version="1.0" encoding="utf-8"?>
 <p:sld xmlns:a="http://schemas.openxmlformats.org/drawingml/2006/main" xmlns:r="http://schemas.openxmlformats.org/officeDocument/2006/relationships" xmlns:p="http://schemas.openxmlformats.org/presentationml/2006/main">
   <p:cSld>
     <p:spTree>
@@ -23438,7 +23536,7 @@
 </p:sld>
 </file>
 
-<file path=ppt/slides/slide35.xml><?xml version="1.0" encoding="utf-8"?>
+<file path=ppt/slides/slide34.xml><?xml version="1.0" encoding="utf-8"?>
 <p:sld xmlns:a="http://schemas.openxmlformats.org/drawingml/2006/main" xmlns:r="http://schemas.openxmlformats.org/officeDocument/2006/relationships" xmlns:p="http://schemas.openxmlformats.org/presentationml/2006/main">
   <p:cSld>
     <p:spTree>
@@ -23527,7 +23625,7 @@
             </a:r>
             <a:r>
               <a:rPr lang="en-US" altLang="en-US" sz="2400" dirty="0"/>
-              <a:t>process of packaging </a:t>
+              <a:t>packaging </a:t>
             </a:r>
             <a:r>
               <a:rPr lang="en-US" altLang="en-US" sz="2400" b="1" dirty="0">
@@ -23592,7 +23690,7 @@
             <a:pPr eaLnBrk="1" hangingPunct="1"/>
             <a:r>
               <a:rPr lang="en-US" altLang="en-US" sz="2400" dirty="0"/>
-              <a:t>It focuses on the </a:t>
+              <a:t>Focuses on the </a:t>
             </a:r>
             <a:r>
               <a:rPr lang="en-US" altLang="en-US" sz="2400" b="1" dirty="0">
@@ -23628,7 +23726,7 @@
 </p:sld>
 </file>
 
-<file path=ppt/slides/slide36.xml><?xml version="1.0" encoding="utf-8"?>
+<file path=ppt/slides/slide35.xml><?xml version="1.0" encoding="utf-8"?>
 <p:sld xmlns:a="http://schemas.openxmlformats.org/drawingml/2006/main" xmlns:r="http://schemas.openxmlformats.org/officeDocument/2006/relationships" xmlns:p="http://schemas.openxmlformats.org/presentationml/2006/main">
   <p:cSld>
     <p:spTree>
@@ -23914,7 +24012,7 @@
 </p:sld>
 </file>
 
-<file path=ppt/slides/slide37.xml><?xml version="1.0" encoding="utf-8"?>
+<file path=ppt/slides/slide36.xml><?xml version="1.0" encoding="utf-8"?>
 <p:sld xmlns:a="http://schemas.openxmlformats.org/drawingml/2006/main" xmlns:r="http://schemas.openxmlformats.org/officeDocument/2006/relationships" xmlns:p="http://schemas.openxmlformats.org/presentationml/2006/main">
   <p:cSld>
     <p:spTree>
@@ -24032,18 +24130,30 @@
           <a:p>
             <a:pPr lvl="1"/>
             <a:r>
-              <a:rPr lang="en-US" altLang="en-US" dirty="0"/>
+              <a:rPr lang="en-US" altLang="en-US" dirty="0">
+                <a:solidFill>
+                  <a:schemeClr val="tx1"/>
+                </a:solidFill>
+              </a:rPr>
               <a:t>Division into component parts</a:t>
             </a:r>
           </a:p>
           <a:p>
             <a:pPr lvl="1"/>
-            <a:endParaRPr lang="en-US" altLang="en-US" dirty="0"/>
+            <a:endParaRPr lang="en-US" altLang="en-US" dirty="0">
+              <a:solidFill>
+                <a:schemeClr val="tx1"/>
+              </a:solidFill>
+            </a:endParaRPr>
           </a:p>
           <a:p>
             <a:pPr lvl="1"/>
             <a:r>
-              <a:rPr lang="en-US" altLang="en-US" dirty="0"/>
+              <a:rPr lang="en-US" altLang="en-US" dirty="0">
+                <a:solidFill>
+                  <a:schemeClr val="tx1"/>
+                </a:solidFill>
+              </a:rPr>
               <a:t>Characterized by sentences that have the words “</a:t>
             </a:r>
             <a:r>
@@ -24055,7 +24165,11 @@
               <a:t>has-a</a:t>
             </a:r>
             <a:r>
-              <a:rPr lang="en-US" altLang="en-US" dirty="0"/>
+              <a:rPr lang="en-US" altLang="en-US" dirty="0">
+                <a:solidFill>
+                  <a:schemeClr val="tx1"/>
+                </a:solidFill>
+              </a:rPr>
               <a:t>”:</a:t>
             </a:r>
           </a:p>
@@ -24147,7 +24261,11 @@
           <a:p>
             <a:pPr lvl="1" eaLnBrk="1" hangingPunct="1"/>
             <a:r>
-              <a:rPr lang="en-US" altLang="en-US" dirty="0"/>
+              <a:rPr lang="en-US" altLang="en-US" dirty="0">
+                <a:solidFill>
+                  <a:schemeClr val="tx1"/>
+                </a:solidFill>
+              </a:rPr>
               <a:t>Drop down level of complexity.</a:t>
             </a:r>
           </a:p>
@@ -24202,7 +24320,7 @@
 </p:sld>
 </file>
 
-<file path=ppt/slides/slide38.xml><?xml version="1.0" encoding="utf-8"?>
+<file path=ppt/slides/slide37.xml><?xml version="1.0" encoding="utf-8"?>
 <p:sld xmlns:a="http://schemas.openxmlformats.org/drawingml/2006/main" xmlns:r="http://schemas.openxmlformats.org/officeDocument/2006/relationships" xmlns:p="http://schemas.openxmlformats.org/presentationml/2006/main">
   <p:cSld>
     <p:spTree>
@@ -24518,7 +24636,7 @@
 </p:sld>
 </file>
 
-<file path=ppt/slides/slide39.xml><?xml version="1.0" encoding="utf-8"?>
+<file path=ppt/slides/slide38.xml><?xml version="1.0" encoding="utf-8"?>
 <p:sld xmlns:a="http://schemas.openxmlformats.org/drawingml/2006/main" xmlns:r="http://schemas.openxmlformats.org/officeDocument/2006/relationships" xmlns:p="http://schemas.openxmlformats.org/presentationml/2006/main">
   <p:cSld>
     <p:spTree>
@@ -25853,272 +25971,7 @@
 </p:sld>
 </file>
 
-<file path=ppt/slides/slide4.xml><?xml version="1.0" encoding="utf-8"?>
-<p:sld xmlns:a="http://schemas.openxmlformats.org/drawingml/2006/main" xmlns:r="http://schemas.openxmlformats.org/officeDocument/2006/relationships" xmlns:p="http://schemas.openxmlformats.org/presentationml/2006/main">
-  <p:cSld>
-    <p:spTree>
-      <p:nvGrpSpPr>
-        <p:cNvPr id="1" name=""/>
-        <p:cNvGrpSpPr/>
-        <p:nvPr/>
-      </p:nvGrpSpPr>
-      <p:grpSpPr>
-        <a:xfrm>
-          <a:off x="0" y="0"/>
-          <a:ext cx="0" cy="0"/>
-          <a:chOff x="0" y="0"/>
-          <a:chExt cx="0" cy="0"/>
-        </a:xfrm>
-      </p:grpSpPr>
-      <p:sp>
-        <p:nvSpPr>
-          <p:cNvPr id="2" name="Title 1"/>
-          <p:cNvSpPr>
-            <a:spLocks noGrp="1"/>
-          </p:cNvSpPr>
-          <p:nvPr>
-            <p:ph type="ctrTitle"/>
-          </p:nvPr>
-        </p:nvSpPr>
-        <p:spPr>
-          <a:xfrm>
-            <a:off x="944217" y="2290046"/>
-            <a:ext cx="10555357" cy="1378942"/>
-          </a:xfrm>
-        </p:spPr>
-        <p:txBody>
-          <a:bodyPr rtlCol="0">
-            <a:normAutofit/>
-          </a:bodyPr>
-          <a:lstStyle/>
-          <a:p>
-            <a:pPr>
-              <a:defRPr/>
-            </a:pPr>
-            <a:r>
-              <a:rPr lang="en-US" dirty="0"/>
-              <a:t>OOA, OOD &amp; OOP</a:t>
-            </a:r>
-          </a:p>
-        </p:txBody>
-      </p:sp>
-      <p:sp>
-        <p:nvSpPr>
-          <p:cNvPr id="5123" name="Slide Number Placeholder 3"/>
-          <p:cNvSpPr>
-            <a:spLocks noGrp="1"/>
-          </p:cNvSpPr>
-          <p:nvPr>
-            <p:ph type="sldNum" sz="quarter" idx="4294967295"/>
-          </p:nvPr>
-        </p:nvSpPr>
-        <p:spPr bwMode="auto">
-          <a:noFill/>
-          <a:extLst>
-            <a:ext uri="{909E8E84-426E-40DD-AFC4-6F175D3DCCD1}">
-              <a14:hiddenFill xmlns:a14="http://schemas.microsoft.com/office/drawing/2010/main">
-                <a:solidFill>
-                  <a:srgbClr val="FFFFFF"/>
-                </a:solidFill>
-              </a14:hiddenFill>
-            </a:ext>
-            <a:ext uri="{91240B29-F687-4F45-9708-019B960494DF}">
-              <a14:hiddenLine xmlns:a14="http://schemas.microsoft.com/office/drawing/2010/main" w="9525">
-                <a:solidFill>
-                  <a:srgbClr val="000000"/>
-                </a:solidFill>
-                <a:miter lim="800000"/>
-                <a:headEnd/>
-                <a:tailEnd/>
-              </a14:hiddenLine>
-            </a:ext>
-          </a:extLst>
-        </p:spPr>
-        <p:txBody>
-          <a:bodyPr/>
-          <a:lstStyle>
-            <a:lvl1pPr>
-              <a:spcBef>
-                <a:spcPct val="20000"/>
-              </a:spcBef>
-              <a:buFont typeface="Arial" panose="020B0604020202020204" pitchFamily="34" charset="0"/>
-              <a:buChar char="•"/>
-              <a:defRPr sz="3200">
-                <a:solidFill>
-                  <a:schemeClr val="tx1"/>
-                </a:solidFill>
-                <a:latin typeface="Calibri" panose="020F0502020204030204" pitchFamily="34" charset="0"/>
-              </a:defRPr>
-            </a:lvl1pPr>
-            <a:lvl2pPr marL="742950" indent="-285750">
-              <a:spcBef>
-                <a:spcPct val="20000"/>
-              </a:spcBef>
-              <a:buFont typeface="Arial" panose="020B0604020202020204" pitchFamily="34" charset="0"/>
-              <a:buChar char="–"/>
-              <a:defRPr sz="2800">
-                <a:solidFill>
-                  <a:schemeClr val="tx1"/>
-                </a:solidFill>
-                <a:latin typeface="Calibri" panose="020F0502020204030204" pitchFamily="34" charset="0"/>
-              </a:defRPr>
-            </a:lvl2pPr>
-            <a:lvl3pPr marL="1143000" indent="-228600">
-              <a:spcBef>
-                <a:spcPct val="20000"/>
-              </a:spcBef>
-              <a:buFont typeface="Arial" panose="020B0604020202020204" pitchFamily="34" charset="0"/>
-              <a:buChar char="•"/>
-              <a:defRPr sz="2400">
-                <a:solidFill>
-                  <a:schemeClr val="tx1"/>
-                </a:solidFill>
-                <a:latin typeface="Calibri" panose="020F0502020204030204" pitchFamily="34" charset="0"/>
-              </a:defRPr>
-            </a:lvl3pPr>
-            <a:lvl4pPr marL="1600200" indent="-228600">
-              <a:spcBef>
-                <a:spcPct val="20000"/>
-              </a:spcBef>
-              <a:buFont typeface="Arial" panose="020B0604020202020204" pitchFamily="34" charset="0"/>
-              <a:buChar char="–"/>
-              <a:defRPr sz="2000">
-                <a:solidFill>
-                  <a:schemeClr val="tx1"/>
-                </a:solidFill>
-                <a:latin typeface="Calibri" panose="020F0502020204030204" pitchFamily="34" charset="0"/>
-              </a:defRPr>
-            </a:lvl4pPr>
-            <a:lvl5pPr marL="2057400" indent="-228600">
-              <a:spcBef>
-                <a:spcPct val="20000"/>
-              </a:spcBef>
-              <a:buFont typeface="Arial" panose="020B0604020202020204" pitchFamily="34" charset="0"/>
-              <a:buChar char="»"/>
-              <a:defRPr sz="2000">
-                <a:solidFill>
-                  <a:schemeClr val="tx1"/>
-                </a:solidFill>
-                <a:latin typeface="Calibri" panose="020F0502020204030204" pitchFamily="34" charset="0"/>
-              </a:defRPr>
-            </a:lvl5pPr>
-            <a:lvl6pPr marL="2514600" indent="-228600" eaLnBrk="0" fontAlgn="base" hangingPunct="0">
-              <a:spcBef>
-                <a:spcPct val="20000"/>
-              </a:spcBef>
-              <a:spcAft>
-                <a:spcPct val="0"/>
-              </a:spcAft>
-              <a:buFont typeface="Arial" panose="020B0604020202020204" pitchFamily="34" charset="0"/>
-              <a:buChar char="»"/>
-              <a:defRPr sz="2000">
-                <a:solidFill>
-                  <a:schemeClr val="tx1"/>
-                </a:solidFill>
-                <a:latin typeface="Calibri" panose="020F0502020204030204" pitchFamily="34" charset="0"/>
-              </a:defRPr>
-            </a:lvl6pPr>
-            <a:lvl7pPr marL="2971800" indent="-228600" eaLnBrk="0" fontAlgn="base" hangingPunct="0">
-              <a:spcBef>
-                <a:spcPct val="20000"/>
-              </a:spcBef>
-              <a:spcAft>
-                <a:spcPct val="0"/>
-              </a:spcAft>
-              <a:buFont typeface="Arial" panose="020B0604020202020204" pitchFamily="34" charset="0"/>
-              <a:buChar char="»"/>
-              <a:defRPr sz="2000">
-                <a:solidFill>
-                  <a:schemeClr val="tx1"/>
-                </a:solidFill>
-                <a:latin typeface="Calibri" panose="020F0502020204030204" pitchFamily="34" charset="0"/>
-              </a:defRPr>
-            </a:lvl7pPr>
-            <a:lvl8pPr marL="3429000" indent="-228600" eaLnBrk="0" fontAlgn="base" hangingPunct="0">
-              <a:spcBef>
-                <a:spcPct val="20000"/>
-              </a:spcBef>
-              <a:spcAft>
-                <a:spcPct val="0"/>
-              </a:spcAft>
-              <a:buFont typeface="Arial" panose="020B0604020202020204" pitchFamily="34" charset="0"/>
-              <a:buChar char="»"/>
-              <a:defRPr sz="2000">
-                <a:solidFill>
-                  <a:schemeClr val="tx1"/>
-                </a:solidFill>
-                <a:latin typeface="Calibri" panose="020F0502020204030204" pitchFamily="34" charset="0"/>
-              </a:defRPr>
-            </a:lvl8pPr>
-            <a:lvl9pPr marL="3886200" indent="-228600" eaLnBrk="0" fontAlgn="base" hangingPunct="0">
-              <a:spcBef>
-                <a:spcPct val="20000"/>
-              </a:spcBef>
-              <a:spcAft>
-                <a:spcPct val="0"/>
-              </a:spcAft>
-              <a:buFont typeface="Arial" panose="020B0604020202020204" pitchFamily="34" charset="0"/>
-              <a:buChar char="»"/>
-              <a:defRPr sz="2000">
-                <a:solidFill>
-                  <a:schemeClr val="tx1"/>
-                </a:solidFill>
-                <a:latin typeface="Calibri" panose="020F0502020204030204" pitchFamily="34" charset="0"/>
-              </a:defRPr>
-            </a:lvl9pPr>
-          </a:lstStyle>
-          <a:p>
-            <a:pPr marL="0" marR="0" lvl="0" indent="0" algn="l" defTabSz="914400" rtl="0" eaLnBrk="1" fontAlgn="auto" latinLnBrk="0" hangingPunct="1">
-              <a:lnSpc>
-                <a:spcPct val="100000"/>
-              </a:lnSpc>
-              <a:spcBef>
-                <a:spcPct val="0"/>
-              </a:spcBef>
-              <a:spcAft>
-                <a:spcPts val="0"/>
-              </a:spcAft>
-              <a:buClrTx/>
-              <a:buSzTx/>
-              <a:buFontTx/>
-              <a:buNone/>
-              <a:tabLst/>
-              <a:defRPr/>
-            </a:pPr>
-            <a:r>
-              <a:rPr kumimoji="0" lang="en-US" altLang="en-US" sz="1200" b="0" i="0" u="none" strike="noStrike" kern="1200" cap="none" spc="0" normalizeH="0" baseline="0" noProof="0" dirty="0">
-                <a:ln>
-                  <a:noFill/>
-                </a:ln>
-                <a:solidFill>
-                  <a:srgbClr val="898989"/>
-                </a:solidFill>
-                <a:effectLst/>
-                <a:uLnTx/>
-                <a:uFillTx/>
-                <a:latin typeface="Calibri" panose="020F0502020204030204" pitchFamily="34" charset="0"/>
-                <a:ea typeface="+mn-ea"/>
-                <a:cs typeface="+mn-cs"/>
-              </a:rPr>
-              <a:t> </a:t>
-            </a:r>
-          </a:p>
-        </p:txBody>
-      </p:sp>
-    </p:spTree>
-    <p:extLst>
-      <p:ext uri="{BB962C8B-B14F-4D97-AF65-F5344CB8AC3E}">
-        <p14:creationId xmlns:p14="http://schemas.microsoft.com/office/powerpoint/2010/main" val="1694737327"/>
-      </p:ext>
-    </p:extLst>
-  </p:cSld>
-  <p:clrMapOvr>
-    <a:masterClrMapping/>
-  </p:clrMapOvr>
-</p:sld>
-</file>
-
-<file path=ppt/slides/slide40.xml><?xml version="1.0" encoding="utf-8"?>
+<file path=ppt/slides/slide39.xml><?xml version="1.0" encoding="utf-8"?>
 <p:sld xmlns:a="http://schemas.openxmlformats.org/drawingml/2006/main" xmlns:r="http://schemas.openxmlformats.org/officeDocument/2006/relationships" xmlns:p="http://schemas.openxmlformats.org/presentationml/2006/main">
   <p:cSld>
     <p:spTree>
@@ -26899,7 +26752,272 @@
 </p:sld>
 </file>
 
-<file path=ppt/slides/slide41.xml><?xml version="1.0" encoding="utf-8"?>
+<file path=ppt/slides/slide4.xml><?xml version="1.0" encoding="utf-8"?>
+<p:sld xmlns:a="http://schemas.openxmlformats.org/drawingml/2006/main" xmlns:r="http://schemas.openxmlformats.org/officeDocument/2006/relationships" xmlns:p="http://schemas.openxmlformats.org/presentationml/2006/main">
+  <p:cSld>
+    <p:spTree>
+      <p:nvGrpSpPr>
+        <p:cNvPr id="1" name=""/>
+        <p:cNvGrpSpPr/>
+        <p:nvPr/>
+      </p:nvGrpSpPr>
+      <p:grpSpPr>
+        <a:xfrm>
+          <a:off x="0" y="0"/>
+          <a:ext cx="0" cy="0"/>
+          <a:chOff x="0" y="0"/>
+          <a:chExt cx="0" cy="0"/>
+        </a:xfrm>
+      </p:grpSpPr>
+      <p:sp>
+        <p:nvSpPr>
+          <p:cNvPr id="2" name="Title 1"/>
+          <p:cNvSpPr>
+            <a:spLocks noGrp="1"/>
+          </p:cNvSpPr>
+          <p:nvPr>
+            <p:ph type="ctrTitle"/>
+          </p:nvPr>
+        </p:nvSpPr>
+        <p:spPr>
+          <a:xfrm>
+            <a:off x="944217" y="2290046"/>
+            <a:ext cx="10555357" cy="1378942"/>
+          </a:xfrm>
+        </p:spPr>
+        <p:txBody>
+          <a:bodyPr rtlCol="0">
+            <a:normAutofit/>
+          </a:bodyPr>
+          <a:lstStyle/>
+          <a:p>
+            <a:pPr>
+              <a:defRPr/>
+            </a:pPr>
+            <a:r>
+              <a:rPr lang="en-US" dirty="0"/>
+              <a:t>OOA, OOD &amp; OOP</a:t>
+            </a:r>
+          </a:p>
+        </p:txBody>
+      </p:sp>
+      <p:sp>
+        <p:nvSpPr>
+          <p:cNvPr id="5123" name="Slide Number Placeholder 3"/>
+          <p:cNvSpPr>
+            <a:spLocks noGrp="1"/>
+          </p:cNvSpPr>
+          <p:nvPr>
+            <p:ph type="sldNum" sz="quarter" idx="4294967295"/>
+          </p:nvPr>
+        </p:nvSpPr>
+        <p:spPr bwMode="auto">
+          <a:noFill/>
+          <a:extLst>
+            <a:ext uri="{909E8E84-426E-40DD-AFC4-6F175D3DCCD1}">
+              <a14:hiddenFill xmlns:a14="http://schemas.microsoft.com/office/drawing/2010/main">
+                <a:solidFill>
+                  <a:srgbClr val="FFFFFF"/>
+                </a:solidFill>
+              </a14:hiddenFill>
+            </a:ext>
+            <a:ext uri="{91240B29-F687-4F45-9708-019B960494DF}">
+              <a14:hiddenLine xmlns:a14="http://schemas.microsoft.com/office/drawing/2010/main" w="9525">
+                <a:solidFill>
+                  <a:srgbClr val="000000"/>
+                </a:solidFill>
+                <a:miter lim="800000"/>
+                <a:headEnd/>
+                <a:tailEnd/>
+              </a14:hiddenLine>
+            </a:ext>
+          </a:extLst>
+        </p:spPr>
+        <p:txBody>
+          <a:bodyPr/>
+          <a:lstStyle>
+            <a:lvl1pPr>
+              <a:spcBef>
+                <a:spcPct val="20000"/>
+              </a:spcBef>
+              <a:buFont typeface="Arial" panose="020B0604020202020204" pitchFamily="34" charset="0"/>
+              <a:buChar char="•"/>
+              <a:defRPr sz="3200">
+                <a:solidFill>
+                  <a:schemeClr val="tx1"/>
+                </a:solidFill>
+                <a:latin typeface="Calibri" panose="020F0502020204030204" pitchFamily="34" charset="0"/>
+              </a:defRPr>
+            </a:lvl1pPr>
+            <a:lvl2pPr marL="742950" indent="-285750">
+              <a:spcBef>
+                <a:spcPct val="20000"/>
+              </a:spcBef>
+              <a:buFont typeface="Arial" panose="020B0604020202020204" pitchFamily="34" charset="0"/>
+              <a:buChar char="–"/>
+              <a:defRPr sz="2800">
+                <a:solidFill>
+                  <a:schemeClr val="tx1"/>
+                </a:solidFill>
+                <a:latin typeface="Calibri" panose="020F0502020204030204" pitchFamily="34" charset="0"/>
+              </a:defRPr>
+            </a:lvl2pPr>
+            <a:lvl3pPr marL="1143000" indent="-228600">
+              <a:spcBef>
+                <a:spcPct val="20000"/>
+              </a:spcBef>
+              <a:buFont typeface="Arial" panose="020B0604020202020204" pitchFamily="34" charset="0"/>
+              <a:buChar char="•"/>
+              <a:defRPr sz="2400">
+                <a:solidFill>
+                  <a:schemeClr val="tx1"/>
+                </a:solidFill>
+                <a:latin typeface="Calibri" panose="020F0502020204030204" pitchFamily="34" charset="0"/>
+              </a:defRPr>
+            </a:lvl3pPr>
+            <a:lvl4pPr marL="1600200" indent="-228600">
+              <a:spcBef>
+                <a:spcPct val="20000"/>
+              </a:spcBef>
+              <a:buFont typeface="Arial" panose="020B0604020202020204" pitchFamily="34" charset="0"/>
+              <a:buChar char="–"/>
+              <a:defRPr sz="2000">
+                <a:solidFill>
+                  <a:schemeClr val="tx1"/>
+                </a:solidFill>
+                <a:latin typeface="Calibri" panose="020F0502020204030204" pitchFamily="34" charset="0"/>
+              </a:defRPr>
+            </a:lvl4pPr>
+            <a:lvl5pPr marL="2057400" indent="-228600">
+              <a:spcBef>
+                <a:spcPct val="20000"/>
+              </a:spcBef>
+              <a:buFont typeface="Arial" panose="020B0604020202020204" pitchFamily="34" charset="0"/>
+              <a:buChar char="»"/>
+              <a:defRPr sz="2000">
+                <a:solidFill>
+                  <a:schemeClr val="tx1"/>
+                </a:solidFill>
+                <a:latin typeface="Calibri" panose="020F0502020204030204" pitchFamily="34" charset="0"/>
+              </a:defRPr>
+            </a:lvl5pPr>
+            <a:lvl6pPr marL="2514600" indent="-228600" eaLnBrk="0" fontAlgn="base" hangingPunct="0">
+              <a:spcBef>
+                <a:spcPct val="20000"/>
+              </a:spcBef>
+              <a:spcAft>
+                <a:spcPct val="0"/>
+              </a:spcAft>
+              <a:buFont typeface="Arial" panose="020B0604020202020204" pitchFamily="34" charset="0"/>
+              <a:buChar char="»"/>
+              <a:defRPr sz="2000">
+                <a:solidFill>
+                  <a:schemeClr val="tx1"/>
+                </a:solidFill>
+                <a:latin typeface="Calibri" panose="020F0502020204030204" pitchFamily="34" charset="0"/>
+              </a:defRPr>
+            </a:lvl6pPr>
+            <a:lvl7pPr marL="2971800" indent="-228600" eaLnBrk="0" fontAlgn="base" hangingPunct="0">
+              <a:spcBef>
+                <a:spcPct val="20000"/>
+              </a:spcBef>
+              <a:spcAft>
+                <a:spcPct val="0"/>
+              </a:spcAft>
+              <a:buFont typeface="Arial" panose="020B0604020202020204" pitchFamily="34" charset="0"/>
+              <a:buChar char="»"/>
+              <a:defRPr sz="2000">
+                <a:solidFill>
+                  <a:schemeClr val="tx1"/>
+                </a:solidFill>
+                <a:latin typeface="Calibri" panose="020F0502020204030204" pitchFamily="34" charset="0"/>
+              </a:defRPr>
+            </a:lvl7pPr>
+            <a:lvl8pPr marL="3429000" indent="-228600" eaLnBrk="0" fontAlgn="base" hangingPunct="0">
+              <a:spcBef>
+                <a:spcPct val="20000"/>
+              </a:spcBef>
+              <a:spcAft>
+                <a:spcPct val="0"/>
+              </a:spcAft>
+              <a:buFont typeface="Arial" panose="020B0604020202020204" pitchFamily="34" charset="0"/>
+              <a:buChar char="»"/>
+              <a:defRPr sz="2000">
+                <a:solidFill>
+                  <a:schemeClr val="tx1"/>
+                </a:solidFill>
+                <a:latin typeface="Calibri" panose="020F0502020204030204" pitchFamily="34" charset="0"/>
+              </a:defRPr>
+            </a:lvl8pPr>
+            <a:lvl9pPr marL="3886200" indent="-228600" eaLnBrk="0" fontAlgn="base" hangingPunct="0">
+              <a:spcBef>
+                <a:spcPct val="20000"/>
+              </a:spcBef>
+              <a:spcAft>
+                <a:spcPct val="0"/>
+              </a:spcAft>
+              <a:buFont typeface="Arial" panose="020B0604020202020204" pitchFamily="34" charset="0"/>
+              <a:buChar char="»"/>
+              <a:defRPr sz="2000">
+                <a:solidFill>
+                  <a:schemeClr val="tx1"/>
+                </a:solidFill>
+                <a:latin typeface="Calibri" panose="020F0502020204030204" pitchFamily="34" charset="0"/>
+              </a:defRPr>
+            </a:lvl9pPr>
+          </a:lstStyle>
+          <a:p>
+            <a:pPr marL="0" marR="0" lvl="0" indent="0" algn="l" defTabSz="914400" rtl="0" eaLnBrk="1" fontAlgn="auto" latinLnBrk="0" hangingPunct="1">
+              <a:lnSpc>
+                <a:spcPct val="100000"/>
+              </a:lnSpc>
+              <a:spcBef>
+                <a:spcPct val="0"/>
+              </a:spcBef>
+              <a:spcAft>
+                <a:spcPts val="0"/>
+              </a:spcAft>
+              <a:buClrTx/>
+              <a:buSzTx/>
+              <a:buFontTx/>
+              <a:buNone/>
+              <a:tabLst/>
+              <a:defRPr/>
+            </a:pPr>
+            <a:r>
+              <a:rPr kumimoji="0" lang="en-US" altLang="en-US" sz="1200" b="0" i="0" u="none" strike="noStrike" kern="1200" cap="none" spc="0" normalizeH="0" baseline="0" noProof="0" dirty="0">
+                <a:ln>
+                  <a:noFill/>
+                </a:ln>
+                <a:solidFill>
+                  <a:srgbClr val="898989"/>
+                </a:solidFill>
+                <a:effectLst/>
+                <a:uLnTx/>
+                <a:uFillTx/>
+                <a:latin typeface="Calibri" panose="020F0502020204030204" pitchFamily="34" charset="0"/>
+                <a:ea typeface="+mn-ea"/>
+                <a:cs typeface="+mn-cs"/>
+              </a:rPr>
+              <a:t> </a:t>
+            </a:r>
+          </a:p>
+        </p:txBody>
+      </p:sp>
+    </p:spTree>
+    <p:extLst>
+      <p:ext uri="{BB962C8B-B14F-4D97-AF65-F5344CB8AC3E}">
+        <p14:creationId xmlns:p14="http://schemas.microsoft.com/office/powerpoint/2010/main" val="1694737327"/>
+      </p:ext>
+    </p:extLst>
+  </p:cSld>
+  <p:clrMapOvr>
+    <a:masterClrMapping/>
+  </p:clrMapOvr>
+</p:sld>
+</file>
+
+<file path=ppt/slides/slide40.xml><?xml version="1.0" encoding="utf-8"?>
 <p:sld xmlns:a="http://schemas.openxmlformats.org/drawingml/2006/main" xmlns:r="http://schemas.openxmlformats.org/officeDocument/2006/relationships" xmlns:p="http://schemas.openxmlformats.org/presentationml/2006/main">
   <p:cSld>
     <p:spTree>
@@ -26984,7 +27102,7 @@
         <p:spPr>
           <a:xfrm>
             <a:off x="1498695" y="1445715"/>
-            <a:ext cx="10236105" cy="4801314"/>
+            <a:ext cx="10236105" cy="4524315"/>
           </a:xfrm>
           <a:prstGeom prst="rect">
             <a:avLst/>
@@ -27489,29 +27607,6 @@
             </a:r>
           </a:p>
           <a:p>
-            <a:pPr lvl="0">
-              <a:defRPr/>
-            </a:pPr>
-            <a:r>
-              <a:rPr lang="en-US" dirty="0"/>
-              <a:t>	If you do not make the child class, it cannot be accessed from outside the package.</a:t>
-            </a:r>
-            <a:endParaRPr kumimoji="0" lang="en-US" sz="1800" b="0" i="0" u="none" strike="noStrike" kern="1200" cap="none" spc="0" normalizeH="0" baseline="0" noProof="0" dirty="0">
-              <a:ln>
-                <a:noFill/>
-              </a:ln>
-              <a:solidFill>
-                <a:srgbClr val="000000"/>
-              </a:solidFill>
-              <a:effectLst/>
-              <a:uLnTx/>
-              <a:uFillTx/>
-              <a:latin typeface="Arial" panose="020B0604020202020204"/>
-              <a:ea typeface="+mn-ea"/>
-              <a:cs typeface="+mn-cs"/>
-            </a:endParaRPr>
-          </a:p>
-          <a:p>
             <a:pPr marL="0" marR="0" lvl="0" indent="0" algn="l" defTabSz="914400" rtl="0" eaLnBrk="1" fontAlgn="auto" latinLnBrk="0" hangingPunct="1">
               <a:lnSpc>
                 <a:spcPct val="100000"/>
@@ -27626,7 +27721,7 @@
 </p:sld>
 </file>
 
-<file path=ppt/slides/slide42.xml><?xml version="1.0" encoding="utf-8"?>
+<file path=ppt/slides/slide41.xml><?xml version="1.0" encoding="utf-8"?>
 <p:sld xmlns:a="http://schemas.openxmlformats.org/drawingml/2006/main" xmlns:r="http://schemas.openxmlformats.org/officeDocument/2006/relationships" xmlns:p="http://schemas.openxmlformats.org/presentationml/2006/main">
   <p:cSld>
     <p:spTree>
@@ -27907,7 +28002,7 @@
 </p:sld>
 </file>
 
-<file path=ppt/slides/slide43.xml><?xml version="1.0" encoding="utf-8"?>
+<file path=ppt/slides/slide42.xml><?xml version="1.0" encoding="utf-8"?>
 <p:sld xmlns:a="http://schemas.openxmlformats.org/drawingml/2006/main" xmlns:r="http://schemas.openxmlformats.org/officeDocument/2006/relationships" xmlns:p="http://schemas.openxmlformats.org/presentationml/2006/main">
   <p:cSld>
     <p:spTree>
@@ -28508,6 +28603,70 @@
     <a:masterClrMapping/>
   </p:clrMapOvr>
   <p:transition/>
+</p:sld>
+</file>
+
+<file path=ppt/slides/slide43.xml><?xml version="1.0" encoding="utf-8"?>
+<p:sld xmlns:a="http://schemas.openxmlformats.org/drawingml/2006/main" xmlns:r="http://schemas.openxmlformats.org/officeDocument/2006/relationships" xmlns:p="http://schemas.openxmlformats.org/presentationml/2006/main">
+  <p:cSld>
+    <p:spTree>
+      <p:nvGrpSpPr>
+        <p:cNvPr id="1" name="">
+          <a:extLst>
+            <a:ext uri="{FF2B5EF4-FFF2-40B4-BE49-F238E27FC236}">
+              <a16:creationId xmlns:a16="http://schemas.microsoft.com/office/drawing/2014/main" id="{84DA25F2-3AE0-BDCF-0880-EDD5EEF55E54}"/>
+            </a:ext>
+          </a:extLst>
+        </p:cNvPr>
+        <p:cNvGrpSpPr/>
+        <p:nvPr/>
+      </p:nvGrpSpPr>
+      <p:grpSpPr>
+        <a:xfrm>
+          <a:off x="0" y="0"/>
+          <a:ext cx="0" cy="0"/>
+          <a:chOff x="0" y="0"/>
+          <a:chExt cx="0" cy="0"/>
+        </a:xfrm>
+      </p:grpSpPr>
+      <p:sp>
+        <p:nvSpPr>
+          <p:cNvPr id="2" name="Title 1">
+            <a:extLst>
+              <a:ext uri="{FF2B5EF4-FFF2-40B4-BE49-F238E27FC236}">
+                <a16:creationId xmlns:a16="http://schemas.microsoft.com/office/drawing/2014/main" id="{6EAE57A2-3A61-C5F8-EEFD-EA2961784338}"/>
+              </a:ext>
+            </a:extLst>
+          </p:cNvPr>
+          <p:cNvSpPr>
+            <a:spLocks noGrp="1"/>
+          </p:cNvSpPr>
+          <p:nvPr>
+            <p:ph type="ctrTitle"/>
+          </p:nvPr>
+        </p:nvSpPr>
+        <p:spPr/>
+        <p:txBody>
+          <a:bodyPr/>
+          <a:lstStyle/>
+          <a:p>
+            <a:r>
+              <a:rPr lang="en-US" dirty="0"/>
+              <a:t>… to here …</a:t>
+            </a:r>
+          </a:p>
+        </p:txBody>
+      </p:sp>
+    </p:spTree>
+    <p:extLst>
+      <p:ext uri="{BB962C8B-B14F-4D97-AF65-F5344CB8AC3E}">
+        <p14:creationId xmlns:p14="http://schemas.microsoft.com/office/powerpoint/2010/main" val="2815624037"/>
+      </p:ext>
+    </p:extLst>
+  </p:cSld>
+  <p:clrMapOvr>
+    <a:masterClrMapping/>
+  </p:clrMapOvr>
 </p:sld>
 </file>
 
@@ -35465,7 +35624,9 @@
           </a:xfrm>
         </p:spPr>
         <p:txBody>
-          <a:bodyPr/>
+          <a:bodyPr>
+            <a:normAutofit lnSpcReduction="10000"/>
+          </a:bodyPr>
           <a:lstStyle/>
           <a:p>
             <a:pPr eaLnBrk="1" hangingPunct="1">
@@ -35506,7 +35667,7 @@
             </a:pPr>
             <a:r>
               <a:rPr lang="en-US" altLang="en-US" dirty="0"/>
-              <a:t>Most common use in OOP when a </a:t>
+              <a:t>Most common in OOP when a </a:t>
             </a:r>
             <a:r>
               <a:rPr lang="en-US" altLang="en-US" b="1" dirty="0">
@@ -35599,7 +35760,26 @@
             </a:pPr>
             <a:r>
               <a:rPr lang="en-US" altLang="en-US" dirty="0"/>
-              <a:t>Late binding, runtime binding, …</a:t>
+              <a:t>Late binding, runtime binding, … </a:t>
+            </a:r>
+          </a:p>
+          <a:p>
+            <a:pPr eaLnBrk="1" hangingPunct="1">
+              <a:buFont typeface="Arial" charset="0"/>
+              <a:buChar char="•"/>
+              <a:defRPr/>
+            </a:pPr>
+            <a:endParaRPr lang="en-US" altLang="en-US" dirty="0"/>
+          </a:p>
+          <a:p>
+            <a:pPr eaLnBrk="1" hangingPunct="1">
+              <a:buFont typeface="Arial" charset="0"/>
+              <a:buChar char="•"/>
+              <a:defRPr/>
+            </a:pPr>
+            <a:r>
+              <a:rPr lang="en-US" altLang="en-US" dirty="0"/>
+              <a:t>(In C++ virtual functions)</a:t>
             </a:r>
           </a:p>
           <a:p>
@@ -37397,70 +37577,6 @@
   <p:cSld>
     <p:spTree>
       <p:nvGrpSpPr>
-        <p:cNvPr id="1" name="">
-          <a:extLst>
-            <a:ext uri="{FF2B5EF4-FFF2-40B4-BE49-F238E27FC236}">
-              <a16:creationId xmlns:a16="http://schemas.microsoft.com/office/drawing/2014/main" id="{84DA25F2-3AE0-BDCF-0880-EDD5EEF55E54}"/>
-            </a:ext>
-          </a:extLst>
-        </p:cNvPr>
-        <p:cNvGrpSpPr/>
-        <p:nvPr/>
-      </p:nvGrpSpPr>
-      <p:grpSpPr>
-        <a:xfrm>
-          <a:off x="0" y="0"/>
-          <a:ext cx="0" cy="0"/>
-          <a:chOff x="0" y="0"/>
-          <a:chExt cx="0" cy="0"/>
-        </a:xfrm>
-      </p:grpSpPr>
-      <p:sp>
-        <p:nvSpPr>
-          <p:cNvPr id="2" name="Title 1">
-            <a:extLst>
-              <a:ext uri="{FF2B5EF4-FFF2-40B4-BE49-F238E27FC236}">
-                <a16:creationId xmlns:a16="http://schemas.microsoft.com/office/drawing/2014/main" id="{6EAE57A2-3A61-C5F8-EEFD-EA2961784338}"/>
-              </a:ext>
-            </a:extLst>
-          </p:cNvPr>
-          <p:cNvSpPr>
-            <a:spLocks noGrp="1"/>
-          </p:cNvSpPr>
-          <p:nvPr>
-            <p:ph type="ctrTitle"/>
-          </p:nvPr>
-        </p:nvSpPr>
-        <p:spPr/>
-        <p:txBody>
-          <a:bodyPr/>
-          <a:lstStyle/>
-          <a:p>
-            <a:r>
-              <a:rPr lang="en-US" dirty="0"/>
-              <a:t>… to here …</a:t>
-            </a:r>
-          </a:p>
-        </p:txBody>
-      </p:sp>
-    </p:spTree>
-    <p:extLst>
-      <p:ext uri="{BB962C8B-B14F-4D97-AF65-F5344CB8AC3E}">
-        <p14:creationId xmlns:p14="http://schemas.microsoft.com/office/powerpoint/2010/main" val="2815624037"/>
-      </p:ext>
-    </p:extLst>
-  </p:cSld>
-  <p:clrMapOvr>
-    <a:masterClrMapping/>
-  </p:clrMapOvr>
-</p:sld>
-</file>
-
-<file path=ppt/slides/slide9.xml><?xml version="1.0" encoding="utf-8"?>
-<p:sld xmlns:a="http://schemas.openxmlformats.org/drawingml/2006/main" xmlns:r="http://schemas.openxmlformats.org/officeDocument/2006/relationships" xmlns:p="http://schemas.openxmlformats.org/presentationml/2006/main">
-  <p:cSld>
-    <p:spTree>
-      <p:nvGrpSpPr>
         <p:cNvPr id="1" name=""/>
         <p:cNvGrpSpPr/>
         <p:nvPr/>
@@ -37528,6 +37644,190 @@
     <p:extLst>
       <p:ext uri="{BB962C8B-B14F-4D97-AF65-F5344CB8AC3E}">
         <p14:creationId xmlns:p14="http://schemas.microsoft.com/office/powerpoint/2010/main" val="3272772986"/>
+      </p:ext>
+    </p:extLst>
+  </p:cSld>
+  <p:clrMapOvr>
+    <a:masterClrMapping/>
+  </p:clrMapOvr>
+  <p:transition/>
+</p:sld>
+</file>
+
+<file path=ppt/slides/slide9.xml><?xml version="1.0" encoding="utf-8"?>
+<p:sld xmlns:a="http://schemas.openxmlformats.org/drawingml/2006/main" xmlns:r="http://schemas.openxmlformats.org/officeDocument/2006/relationships" xmlns:p="http://schemas.openxmlformats.org/presentationml/2006/main">
+  <p:cSld>
+    <p:spTree>
+      <p:nvGrpSpPr>
+        <p:cNvPr id="1" name=""/>
+        <p:cNvGrpSpPr/>
+        <p:nvPr/>
+      </p:nvGrpSpPr>
+      <p:grpSpPr>
+        <a:xfrm>
+          <a:off x="0" y="0"/>
+          <a:ext cx="0" cy="0"/>
+          <a:chOff x="0" y="0"/>
+          <a:chExt cx="0" cy="0"/>
+        </a:xfrm>
+      </p:grpSpPr>
+      <p:sp>
+        <p:nvSpPr>
+          <p:cNvPr id="26627" name="Rectangle 3"/>
+          <p:cNvSpPr>
+            <a:spLocks noGrp="1" noChangeArrowheads="1"/>
+          </p:cNvSpPr>
+          <p:nvPr>
+            <p:ph idx="1"/>
+          </p:nvPr>
+        </p:nvSpPr>
+        <p:spPr>
+          <a:xfrm>
+            <a:off x="1301469" y="1092424"/>
+            <a:ext cx="7967958" cy="5348835"/>
+          </a:xfrm>
+        </p:spPr>
+        <p:txBody>
+          <a:bodyPr>
+            <a:normAutofit/>
+          </a:bodyPr>
+          <a:lstStyle/>
+          <a:p>
+            <a:pPr marL="457200" lvl="1" indent="0" algn="just" eaLnBrk="1" hangingPunct="1">
+              <a:lnSpc>
+                <a:spcPct val="90000"/>
+              </a:lnSpc>
+              <a:buNone/>
+            </a:pPr>
+            <a:r>
+              <a:rPr lang="en-US" altLang="en-US" b="1" dirty="0">
+                <a:solidFill>
+                  <a:schemeClr val="tx1"/>
+                </a:solidFill>
+                <a:cs typeface="Times New Roman" panose="02020603050405020304" pitchFamily="18" charset="0"/>
+              </a:rPr>
+              <a:t>Waterfall Software Development </a:t>
+            </a:r>
+          </a:p>
+          <a:p>
+            <a:pPr lvl="1" algn="just"/>
+            <a:endParaRPr lang="en-US" altLang="en-US" dirty="0">
+              <a:solidFill>
+                <a:schemeClr val="tx1"/>
+              </a:solidFill>
+              <a:cs typeface="Times New Roman" panose="02020603050405020304" pitchFamily="18" charset="0"/>
+            </a:endParaRPr>
+          </a:p>
+          <a:p>
+            <a:pPr lvl="1" algn="just"/>
+            <a:r>
+              <a:rPr lang="en-US" altLang="en-US" dirty="0">
+                <a:solidFill>
+                  <a:schemeClr val="tx1"/>
+                </a:solidFill>
+                <a:cs typeface="Times New Roman" panose="02020603050405020304" pitchFamily="18" charset="0"/>
+              </a:rPr>
+              <a:t>Do everything in steps</a:t>
+            </a:r>
+          </a:p>
+          <a:p>
+            <a:pPr lvl="1" algn="just"/>
+            <a:endParaRPr lang="en-US" altLang="en-US" dirty="0">
+              <a:solidFill>
+                <a:schemeClr val="tx1"/>
+              </a:solidFill>
+              <a:cs typeface="Times New Roman" panose="02020603050405020304" pitchFamily="18" charset="0"/>
+            </a:endParaRPr>
+          </a:p>
+          <a:p>
+            <a:pPr lvl="1" algn="just"/>
+            <a:r>
+              <a:rPr lang="en-US" altLang="en-US" dirty="0">
+                <a:solidFill>
+                  <a:schemeClr val="tx1"/>
+                </a:solidFill>
+                <a:cs typeface="Times New Roman" panose="02020603050405020304" pitchFamily="18" charset="0"/>
+              </a:rPr>
+              <a:t>Requirement analysis</a:t>
+            </a:r>
+          </a:p>
+          <a:p>
+            <a:pPr lvl="1" algn="just"/>
+            <a:endParaRPr lang="en-US" altLang="en-US" dirty="0">
+              <a:solidFill>
+                <a:schemeClr val="tx1"/>
+              </a:solidFill>
+              <a:cs typeface="Times New Roman" panose="02020603050405020304" pitchFamily="18" charset="0"/>
+            </a:endParaRPr>
+          </a:p>
+          <a:p>
+            <a:pPr lvl="1" algn="just"/>
+            <a:r>
+              <a:rPr lang="en-US" altLang="en-US" dirty="0">
+                <a:solidFill>
+                  <a:schemeClr val="tx1"/>
+                </a:solidFill>
+                <a:cs typeface="Times New Roman" panose="02020603050405020304" pitchFamily="18" charset="0"/>
+              </a:rPr>
+              <a:t>Design</a:t>
+            </a:r>
+          </a:p>
+          <a:p>
+            <a:pPr lvl="1" algn="just"/>
+            <a:endParaRPr lang="en-US" altLang="en-US" dirty="0">
+              <a:solidFill>
+                <a:schemeClr val="tx1"/>
+              </a:solidFill>
+              <a:cs typeface="Times New Roman" panose="02020603050405020304" pitchFamily="18" charset="0"/>
+            </a:endParaRPr>
+          </a:p>
+          <a:p>
+            <a:pPr lvl="1" algn="just"/>
+            <a:r>
+              <a:rPr lang="en-US" altLang="en-US" dirty="0">
+                <a:solidFill>
+                  <a:schemeClr val="tx1"/>
+                </a:solidFill>
+                <a:cs typeface="Times New Roman" panose="02020603050405020304" pitchFamily="18" charset="0"/>
+              </a:rPr>
+              <a:t>Implementation</a:t>
+            </a:r>
+          </a:p>
+          <a:p>
+            <a:pPr lvl="1" algn="just"/>
+            <a:endParaRPr lang="en-US" altLang="en-US" dirty="0">
+              <a:solidFill>
+                <a:schemeClr val="tx1"/>
+              </a:solidFill>
+              <a:cs typeface="Times New Roman" panose="02020603050405020304" pitchFamily="18" charset="0"/>
+            </a:endParaRPr>
+          </a:p>
+          <a:p>
+            <a:pPr lvl="1" algn="just"/>
+            <a:r>
+              <a:rPr lang="en-US" altLang="en-US" dirty="0">
+                <a:solidFill>
+                  <a:schemeClr val="tx1"/>
+                </a:solidFill>
+                <a:cs typeface="Times New Roman" panose="02020603050405020304" pitchFamily="18" charset="0"/>
+              </a:rPr>
+              <a:t>Done</a:t>
+            </a:r>
+          </a:p>
+          <a:p>
+            <a:pPr eaLnBrk="1" hangingPunct="1">
+              <a:lnSpc>
+                <a:spcPct val="90000"/>
+              </a:lnSpc>
+            </a:pPr>
+            <a:endParaRPr lang="en-US" altLang="en-US" dirty="0"/>
+          </a:p>
+        </p:txBody>
+      </p:sp>
+    </p:spTree>
+    <p:extLst>
+      <p:ext uri="{BB962C8B-B14F-4D97-AF65-F5344CB8AC3E}">
+        <p14:creationId xmlns:p14="http://schemas.microsoft.com/office/powerpoint/2010/main" val="1740188958"/>
       </p:ext>
     </p:extLst>
   </p:cSld>

</xml_diff>